<commit_message>
docs: improve prose for readability
</commit_message>
<xml_diff>
--- a/presentations/business.pptx
+++ b/presentations/business.pptx
@@ -3477,7 +3477,7 @@
                 </a:solidFill>
                 <a:latin typeface="Calibri"/>
               </a:rPr>
-              <a:t>The second strongest signal in the whole tool is whether the fees are paid. A payment plan is cheaper than a tutor and it addresses the thing itself, not the symptom. If the tool is going to point at unpaid fees, the school should do something about unpaid fees.</a:t>
+              <a:t>The second strongest signal in the whole tool is whether the fees are paid. A payment plan is cheaper than a tutor and it treats the cause, not the symptom. If the tool points at unpaid fees, the school should do something about unpaid fees.</a:t>
             </a:r>
           </a:p>
           <a:p>
@@ -3515,7 +3515,7 @@
                 </a:solidFill>
                 <a:latin typeface="Calibri"/>
               </a:rPr>
-              <a:t>The gender gap was measured once, on one cohort. Put it in the annual reporting line and give it an owner.</a:t>
+              <a:t>The gender gap was measured once, on one group. Put it in the annual reporting line and give it an owner.</a:t>
             </a:r>
           </a:p>
         </p:txBody>
@@ -3634,7 +3634,7 @@
                 </a:solidFill>
                 <a:latin typeface="Calibri"/>
               </a:rPr>
-              <a:t>It costs a term of nobody's time and it buys the only thing worth buying at this stage, which is evidence.</a:t>
+              <a:t>It costs a term of nobody's time. And it buys the only thing worth buying at this stage. Evidence.</a:t>
             </a:r>
           </a:p>
           <a:p>
@@ -3672,7 +3672,7 @@
                 </a:solidFill>
                 <a:latin typeface="Calibri"/>
               </a:rPr>
-              <a:t>A ranked list for the tutoring team. Read by a person, acted on by a person. Not a label attached to a student's record, which is a thing that follows them around.</a:t>
+              <a:t>A ranked list for the tutoring team. Read by a person, acted on by a person. Not a label stuck on a student's record. That is a thing that follows them around.</a:t>
             </a:r>
           </a:p>
         </p:txBody>
@@ -8071,7 +8071,7 @@
                 </a:solidFill>
                 <a:latin typeface="Calibri"/>
               </a:rPr>
-              <a:t>The school already knows this is happening. What it does not know is which students, and it does not find out until the first exam results come back, by which point half the year is gone and the student is usually already gone with it.</a:t>
+              <a:t>The school already knows this is happening. What it does not know is which students. It finds out when the first exam results come back. By then half the year is gone. And the student is usually gone too.</a:t>
             </a:r>
           </a:p>
         </p:txBody>
@@ -8152,7 +8152,7 @@
                 </a:solidFill>
                 <a:latin typeface="Calibri"/>
               </a:rPr>
-              <a:t>is the tuition a single retained student pays back over a three year degree. A deliberately low estimate. The real loss to that student, and to the country, is larger and harder to defend, so it is left out.</a:t>
+              <a:t>is the tuition one saved student pays back over a three year degree. A low estimate on purpose. The real loss to the student and the country is larger and harder to pin down. So it is left out.</a:t>
             </a:r>
           </a:p>
         </p:txBody>
@@ -8350,7 +8350,7 @@
                 </a:solidFill>
                 <a:latin typeface="Calibri"/>
               </a:rPr>
-              <a:t>That was a deliberate choice, and it costs accuracy. A tool that waits for first-semester results would be far more certain. It would also be useless, because by then the student has already decided.</a:t>
+              <a:t>That was a deliberate choice and it costs accuracy. A tool that waits for first-term results would be far more certain. It would also be useless. By then the student has already decided.</a:t>
             </a:r>
           </a:p>
           <a:p>
@@ -8388,7 +8388,7 @@
                 </a:solidFill>
                 <a:latin typeface="Calibri"/>
               </a:rPr>
-              <a:t>Most at risk at the top. Not a label, not a verdict, and never a number shown to a student. A starting point for a conversation, twelve months before it would otherwise happen.</a:t>
+              <a:t>Most at risk at the top. Not a label. Not a verdict. Never a number shown to a student. A starting point for a conversation, twelve months early.</a:t>
             </a:r>
           </a:p>
         </p:txBody>
@@ -9382,7 +9382,7 @@
                 </a:solidFill>
                 <a:latin typeface="Calibri"/>
               </a:rPr>
-              <a:t>Eighty are missed. That is the honest number and it is not going to be zero. No tool that runs on an enrollment form is going to find everyone, and a tool that claimed to would be lying.</a:t>
+              <a:t>Eighty are missed. That is the honest number and it will not be zero. No tool that runs on an enrollment form finds everyone. A tool that claimed to would be lying.</a:t>
             </a:r>
           </a:p>
           <a:p>
@@ -9482,7 +9482,7 @@
                 </a:solidFill>
                 <a:latin typeface="Calibri"/>
               </a:rPr>
-              <a:t>students on the list. That is roughly one in two, and it is set by what the tutoring team can staff, not by the tool.</a:t>
+              <a:t>students on the list. That is roughly one in two. It is set by what the tutoring team can staff, not by the tool.</a:t>
             </a:r>
           </a:p>
         </p:txBody>
@@ -9620,7 +9620,7 @@
                 </a:solidFill>
                 <a:latin typeface="Calibri"/>
               </a:rPr>
-              <a:t>Three assumptions, all stated, all conservative. Change any one and the answer moves, which is why the curve is here and not just the number.</a:t>
+              <a:t>Three assumptions, all stated, all careful. Change any one and the answer moves. That is why the curve is here, not just the number.</a:t>
             </a:r>
           </a:p>
         </p:txBody>
@@ -9686,7 +9686,7 @@
                 </a:solidFill>
                 <a:latin typeface="Calibri"/>
               </a:rPr>
-              <a:t>A retained student is worth about 2,100 EUR.</a:t>
+              <a:t>A saved student is worth about 2,100 EUR.</a:t>
             </a:r>
           </a:p>
           <a:p>
@@ -9743,7 +9743,7 @@
                 </a:solidFill>
                 <a:latin typeface="Calibri"/>
               </a:rPr>
-              <a:t>So a student the tool finds is worth roughly 630 EUR in expectation, not 2,100.</a:t>
+              <a:t>So a student the tool finds is worth about 630 EUR on average, not 2,100.</a:t>
             </a:r>
           </a:p>
           <a:p>
@@ -9781,7 +9781,7 @@
                 </a:solidFill>
                 <a:latin typeface="Calibri"/>
               </a:rPr>
-              <a:t>The school knows this number. I do not, so all three are shown.</a:t>
+              <a:t>The school knows this number. I do not. So all three are shown.</a:t>
             </a:r>
           </a:p>
         </p:txBody>
@@ -10134,7 +10134,7 @@
                 </a:solidFill>
                 <a:latin typeface="Calibri"/>
               </a:rPr>
-              <a:t>Value per 1,000 students. Best case is the most profitable cutoff. As deployed is the 1 in 2 the team can staff. The gap at 150 EUR is 1,700 EUR, so fitting the tool to the team is nearly free.</a:t>
+              <a:t>Value per 1,000 students. Best case is the most profitable cutoff. As deployed is the 1 in 2 the team can staff. The gap at 150 EUR is 1,700 EUR. So fitting the tool to the team is nearly free.</a:t>
             </a:r>
           </a:p>
         </p:txBody>
@@ -10176,7 +10176,7 @@
                 </a:solidFill>
                 <a:latin typeface="Calibri"/>
               </a:rPr>
-              <a:t>At 150 EUR a conversation, a save returns four times what a contact costs. The money says reach out broadly. There is barely any triage left to do.</a:t>
+              <a:t>At 150 EUR a conversation, a save returns four times what a contact costs. The money says reach out broadly. There is barely any sorting left to do.</a:t>
             </a:r>
           </a:p>
         </p:txBody>
@@ -10821,7 +10821,7 @@
                 </a:solidFill>
                 <a:latin typeface="Calibri"/>
               </a:rPr>
-              <a:t>That is the real cost of this tool, and it is not paid in euros. It is paid by a student who is pulled into a retention conversation they did not need, and who has just been told, in effect, that a system thinks they are failing.</a:t>
+              <a:t>That is the real cost of this tool and it is not paid in euros. It is paid by a student pulled into a help conversation they did not need. A student just told, in effect, that a system thinks they are failing.</a:t>
             </a:r>
           </a:p>
           <a:p>
@@ -10840,7 +10840,7 @@
                 </a:solidFill>
                 <a:latin typeface="Calibri"/>
               </a:rPr>
-              <a:t>The number can be driven down. Flag fewer students and fewer graduates get bothered. But every student cut from the list is also a leaver the team never reaches, and the 80 who are missed today becomes 120.</a:t>
+              <a:t>The number can be driven down. Flag fewer students and fewer graduates get bothered. But every student cut from the list is also a leaver the team never reaches. And the 80 missed today becomes 120.</a:t>
             </a:r>
           </a:p>
         </p:txBody>
@@ -10882,7 +10882,7 @@
                 </a:solidFill>
                 <a:latin typeface="Calibri"/>
               </a:rPr>
-              <a:t>This is the trade, and it does not go away.</a:t>
+              <a:t>This is the trade and it does not go away.</a:t>
             </a:r>
           </a:p>
           <a:p>
@@ -10901,7 +10901,7 @@
                 </a:solidFill>
                 <a:latin typeface="Calibri"/>
               </a:rPr>
-              <a:t>There is no setting where the tool finds more leavers and bothers fewer graduates. Moving one moves the other. The only question is where the school wants to sit, and that is a judgement about students, not a calculation.</a:t>
+              <a:t>The tool cannot do both at once. Find more leavers and it bothers more graduates. Bother fewer graduates and it finds fewer leavers. Where the school sits is a judgement about students, not a calculation.</a:t>
             </a:r>
           </a:p>
         </p:txBody>
@@ -11042,7 +11042,7 @@
                 </a:solidFill>
                 <a:latin typeface="Calibri"/>
               </a:rPr>
-              <a:t>The tool was checked across gender, age, scholarship, and debt. Three of the four came back clean, in the sense that the tool reports gaps that already exist in the world rather than inventing them. Gender did not.</a:t>
+              <a:t>The tool was checked across gender, age, scholarship, and debt. Three of the four came back clean. There the tool reflects gaps that already exist in the world rather than inventing them. Gender did not.</a:t>
             </a:r>
           </a:p>
         </p:txBody>
@@ -11440,7 +11440,7 @@
                 </a:solidFill>
                 <a:latin typeface="Calibri"/>
               </a:rPr>
-              <a:t>The tool flags men twice as often as women, so a check on flagging rates says men are over-contacted and stops there. That check is not wrong. It is just answering a different question.</a:t>
+              <a:t>The tool flags men twice as often as women. So a check on flagging rates says men are over-contacted and stops there. That check is not wrong. It just answers a different question.</a:t>
             </a:r>
           </a:p>
           <a:p>
@@ -11501,7 +11501,7 @@
                 </a:solidFill>
                 <a:latin typeface="Calibri"/>
               </a:rPr>
-              <a:t>The students this tool exists to reach are being missed, and they are being missed unevenly.</a:t>
+              <a:t>The students this tool exists to reach are being missed. And they are being missed unevenly.</a:t>
             </a:r>
           </a:p>
         </p:txBody>
@@ -11918,7 +11918,7 @@
                 </a:solidFill>
                 <a:latin typeface="Calibri"/>
               </a:rPr>
-              <a:t>Thirty fewer students are reached, every thousand.</a:t>
+              <a:t>Thirty fewer students are reached in every thousand.</a:t>
             </a:r>
           </a:p>
           <a:p>
@@ -11937,7 +11937,7 @@
                 </a:solidFill>
                 <a:latin typeface="Calibri"/>
               </a:rPr>
-              <a:t>That is a real cost and it should be written down plainly rather than buried in an appendix. Thirty students who would have been caught, now will not be.</a:t>
+              <a:t>That is a real cost and it should be written down plainly, not buried in an appendix. Thirty students who would have been caught now will not be.</a:t>
             </a:r>
           </a:p>
           <a:p>
@@ -11956,7 +11956,7 @@
                 </a:solidFill>
                 <a:latin typeface="Calibri"/>
               </a:rPr>
-              <a:t>What it buys is that those thirty are not disproportionately women.</a:t>
+              <a:t>What it buys is that those thirty are not loaded onto women.</a:t>
             </a:r>
           </a:p>
           <a:p>
@@ -12056,7 +12056,7 @@
                 </a:solidFill>
                 <a:latin typeface="Calibri"/>
               </a:rPr>
-              <a:t>A second correction closes the same gap and looks better on paper, because overall accuracy goes up.</a:t>
+              <a:t>A second correction closes the same gap and looks better on paper. Overall accuracy goes up.</a:t>
             </a:r>
           </a:p>
           <a:p>
@@ -12075,7 +12075,7 @@
                 </a:solidFill>
                 <a:latin typeface="Calibri"/>
               </a:rPr>
-              <a:t>It gets there by contacting fewer students of every kind. It closes the gap by helping fewer people, and it costs seventy fewer leavers found instead of thirty.</a:t>
+              <a:t>It gets there by contacting fewer students of every kind. It closes the gap by helping fewer people. And it costs seventy fewer leavers found instead of thirty.</a:t>
             </a:r>
           </a:p>
           <a:p>
@@ -12136,7 +12136,7 @@
                 </a:solidFill>
                 <a:latin typeface="Calibri"/>
               </a:rPr>
-              <a:t>This is the school's decision, not the model's.</a:t>
+              <a:t>This is the school's decision, not the tool's.</a:t>
             </a:r>
           </a:p>
           <a:p>
@@ -12458,7 +12458,7 @@
                 </a:solidFill>
                 <a:latin typeface="Calibri"/>
               </a:rPr>
-              <a:t>The tool produces its list. Nobody is contacted. At the end of term, compare who it flagged against who actually left, and against who the tutors would have worried about anyway.
+              <a:t>The tool produces its list. Nobody is contacted. At the end of term, compare who it flagged against who actually left. And against who the tutors would have worried about anyway.
 If it does not beat the tutors, it does not deploy.</a:t>
             </a:r>
           </a:p>
@@ -12624,8 +12624,8 @@
                 </a:solidFill>
                 <a:latin typeface="Calibri"/>
               </a:rPr>
-              <a:t>A single department runs it for real. The list goes to a tutor, the tutor decides who to call.
-This measures the thing nobody has measured yet, which is whether reaching out actually retains anyone. Every number on slide 5 rests on an assumption of three in ten. This is where that gets checked.</a:t>
+              <a:t>A single department runs it for real. The list goes to a tutor. The tutor decides who to call.
+This measures the thing nobody has measured yet. Whether reaching out actually keeps anyone. Every number on slide 5 rests on an assumption of three in ten. This is where that gets checked.</a:t>
             </a:r>
           </a:p>
         </p:txBody>
@@ -12791,7 +12791,7 @@
                 <a:latin typeface="Calibri"/>
               </a:rPr>
               <a:t>School-wide, with the gender gap re-measured at every intake and reported to whoever owns this decision.
-The gap was measured on one cohort of 130 women. It is not the kind of thing that stays fixed on its own.</a:t>
+The gap was measured on one group of 130 women who left. It is not the kind of thing that stays fixed on its own.</a:t>
             </a:r>
           </a:p>
         </p:txBody>

</xml_diff>

<commit_message>
fix: reconcile shipped model across artifacts and close review gaps
</commit_message>
<xml_diff>
--- a/presentations/business.pptx
+++ b/presentations/business.pptx
@@ -3477,7 +3477,7 @@
                 </a:solidFill>
                 <a:latin typeface="Calibri"/>
               </a:rPr>
-              <a:t>The second strongest signal in the whole tool is whether the fees are paid. A payment plan is cheaper than a tutor and it treats the cause, not the symptom. If the tool points at unpaid fees, the school should do something about unpaid fees.</a:t>
+              <a:t>The single strongest signals in the tool are which course a student is on and what a parent does, and neither is something a student can change. That is why the tool is a prompt, not a verdict. The strongest signal the school can actually change is whether the fees are paid. A payment plan is cheaper than a tutor and treats the cause, not the symptom.</a:t>
             </a:r>
           </a:p>
           <a:p>
@@ -8010,7 +8010,7 @@
                 </a:solidFill>
                 <a:latin typeface="Calibri"/>
               </a:rPr>
-              <a:t>One dot is ten students. The filled ones do not graduate.</a:t>
+              <a:t>One dot is ten students. The filled ones do not graduate. The rate is 391 in 1,000 among the 3,630 whose outcome is settled, after setting aside 794 still enrolled.</a:t>
             </a:r>
           </a:p>
         </p:txBody>
@@ -9869,7 +9869,7 @@
                           </a:solidFill>
                           <a:latin typeface="Calibri"/>
                         </a:rPr>
-                        <a:t>As deployed</a:t>
+                        <a:t>At 1 in 2</a:t>
                       </a:r>
                     </a:p>
                   </a:txBody>
@@ -10106,7 +10106,7 @@
         <p:spPr>
           <a:xfrm>
             <a:off x="566928" y="5669280"/>
-            <a:ext cx="5394960" cy="548640"/>
+            <a:ext cx="5394960" cy="640080"/>
           </a:xfrm>
           <a:prstGeom prst="rect">
             <a:avLst/>
@@ -10134,7 +10134,7 @@
                 </a:solidFill>
                 <a:latin typeface="Calibri"/>
               </a:rPr>
-              <a:t>Value per 1,000 students. Best case is the most profitable cutoff. As deployed is the 1 in 2 the team can staff. The gap at 150 EUR is 1,700 EUR. So fitting the tool to the team is nearly free.</a:t>
+              <a:t>Value per 1,000 students. Best case is the most profitable cutoff. At 1 in 2 is the list the team can actually staff, and the gap between them at 150 EUR is only 1,700 EUR. So fitting the tool to the team is nearly free. Slide 8 is the thing that is not free.</a:t>
             </a:r>
           </a:p>
         </p:txBody>
@@ -11042,7 +11042,7 @@
                 </a:solidFill>
                 <a:latin typeface="Calibri"/>
               </a:rPr>
-              <a:t>The tool was checked across gender, age, scholarship, and debt. Three of the four came back clean. There the tool reflects gaps that already exist in the world rather than inventing them. Gender did not.</a:t>
+              <a:t>The tool was checked across gender, age, scholarship, and debt. Gender is the one that fails on fairness. The other three flag groups that really do drop out more, though age still needs a closer look.</a:t>
             </a:r>
           </a:p>
         </p:txBody>
@@ -11937,7 +11937,7 @@
                 </a:solidFill>
                 <a:latin typeface="Calibri"/>
               </a:rPr>
-              <a:t>That is a real cost and it should be written down plainly, not buried in an appendix. Thirty students who would have been caught now will not be.</a:t>
+              <a:t>That is a real cost and it should be written down plainly, not buried in an appendix. Thirty students who would have been caught now will not be. In money that is about 8,000 EUR per 1,000 students at a 150 EUR contact, and the catch rate falls from about 8 in 10 to 7 in 10.</a:t>
             </a:r>
           </a:p>
           <a:p>

</xml_diff>

<commit_message>
feat(step-5): measure and document the ranking seam
Measure that the ExponentiatedGradient ranking collapses to five bands
(PR-AUC 0.822 to 0.617), so the shipped fair model picks the flag set
and the base model orders it. The fair set of 410 per 1,000 fits the
450 the team can staff, which is also what first brings the list inside
capacity: the unmitigated 483 overshoots it by 33. Document the seam and
its one failure case across notebook 05, the report, and both decks, add
the capacity print to notebook 05, and correct the parental-occupation
dummy count to 78 to 24.
</commit_message>
<xml_diff>
--- a/presentations/business.pptx
+++ b/presentations/business.pptx
@@ -8631,7 +8631,7 @@
                 </a:solidFill>
                 <a:latin typeface="Calibri"/>
               </a:rPr>
-              <a:t>students are flagged, which is what the tutoring team can actually handle</a:t>
+              <a:t>students are flagged, sized against what the tutoring team can handle</a:t>
             </a:r>
           </a:p>
         </p:txBody>
@@ -9482,7 +9482,7 @@
                 </a:solidFill>
                 <a:latin typeface="Calibri"/>
               </a:rPr>
-              <a:t>students on the list. That is roughly one in two. It is set by what the tutoring team can staff, not by the tool.</a:t>
+              <a:t>students the tool flags, roughly one in two. That is more than the tutoring team can staff, and the fairness fix on slide 8 is what brings the list back within reach.</a:t>
             </a:r>
           </a:p>
         </p:txBody>
@@ -10134,7 +10134,7 @@
                 </a:solidFill>
                 <a:latin typeface="Calibri"/>
               </a:rPr>
-              <a:t>Value per 1,000 students. Best case is the most profitable cutoff. At 1 in 2 is the list the team can actually staff, and the gap between them at 150 EUR is only 1,700 EUR. So fitting the tool to the team is nearly free. Slide 8 is the thing that is not free.</a:t>
+              <a:t>Value per 1,000 students. Best case is the most profitable cutoff. At 1 in 2 is the cutoff the tool deploys at, and the gap between them at 150 EUR is only 1,700 EUR. So aiming the tool at the team's capacity is nearly free. Slide 8 is the thing that is not free.</a:t>
             </a:r>
           </a:p>
         </p:txBody>
@@ -11976,6 +11976,25 @@
                 <a:latin typeface="Calibri"/>
               </a:rPr>
               <a:t>The correction does not make the tool better. It makes it evenly bad.</a:t>
+            </a:r>
+          </a:p>
+          <a:p>
+            <a:pPr algn="l">
+              <a:lnSpc>
+                <a:spcPct val="125000"/>
+              </a:lnSpc>
+              <a:spcAft>
+                <a:spcPts val="800"/>
+              </a:spcAft>
+            </a:pPr>
+            <a:r>
+              <a:rPr sz="1300" b="0">
+                <a:solidFill>
+                  <a:srgbClr val="595959"/>
+                </a:solidFill>
+                <a:latin typeface="Calibri"/>
+              </a:rPr>
+              <a:t>The list of about 410 fits what the team can reach, so everyone on it is contacted.</a:t>
             </a:r>
           </a:p>
         </p:txBody>

</xml_diff>

<commit_message>
style: fix grammar and paragraph flow
</commit_message>
<xml_diff>
--- a/presentations/business.pptx
+++ b/presentations/business.pptx
@@ -3439,7 +3439,7 @@
                 </a:solidFill>
                 <a:latin typeface="Calibri"/>
               </a:rPr>
-              <a:t>Not on a portal, not in a letter, not read out by a tutor. A person told they are seventy percent likely to fail has been handed a prediction, not help.</a:t>
+              <a:t>It appears on no portal and in no letter, and no tutor reads it out, because a prediction handed to a person is not help.</a:t>
             </a:r>
           </a:p>
           <a:p>
@@ -3477,7 +3477,7 @@
                 </a:solidFill>
                 <a:latin typeface="Calibri"/>
               </a:rPr>
-              <a:t>The single strongest signals in the tool are which course a student is on and what a parent does, and neither is something a student can change. That is why the tool is a prompt, not a verdict. The strongest signal the school can actually change is whether the fees are paid. A payment plan is cheaper than a tutor and treats the cause, not the symptom.</a:t>
+              <a:t>The strongest signals, a student's course and a parent's job, are not things they can change, so the one that can be is unpaid fees, and a payment plan is cheaper than a tutor and treats the cause.</a:t>
             </a:r>
           </a:p>
           <a:p>
@@ -3515,7 +3515,7 @@
                 </a:solidFill>
                 <a:latin typeface="Calibri"/>
               </a:rPr>
-              <a:t>The gender gap was measured once, on one group. Put it in the annual reporting line and give it an owner.</a:t>
+              <a:t>It was measured only once, on a single group, so it belongs in the annual reporting line with a named owner.</a:t>
             </a:r>
           </a:p>
         </p:txBody>
@@ -3615,7 +3615,7 @@
                 </a:solidFill>
                 <a:latin typeface="Calibri"/>
               </a:rPr>
-              <a:t>One term. The tool runs, nobody is contacted, and at the end we know whether it beats a tutor's judgement.</a:t>
+              <a:t>For one term the tool runs and nobody is contacted, so that by the end we know whether it beats a tutor's judgement.</a:t>
             </a:r>
           </a:p>
           <a:p>
@@ -3634,7 +3634,7 @@
                 </a:solidFill>
                 <a:latin typeface="Calibri"/>
               </a:rPr>
-              <a:t>It costs a term of nobody's time. And it buys the only thing worth buying at this stage. Evidence.</a:t>
+              <a:t>It costs a term of nobody's time, and it buys the one thing worth buying at this stage, which is evidence.</a:t>
             </a:r>
           </a:p>
           <a:p>
@@ -3672,7 +3672,7 @@
                 </a:solidFill>
                 <a:latin typeface="Calibri"/>
               </a:rPr>
-              <a:t>A ranked list for the tutoring team. Read by a person, acted on by a person. Not a label stuck on a student's record. That is a thing that follows them around.</a:t>
+              <a:t>It should be a ranked list that a person reads and acts on, rather than a label stuck on a student's record that follows them around.</a:t>
             </a:r>
           </a:p>
         </p:txBody>
@@ -3714,7 +3714,7 @@
                 </a:solidFill>
                 <a:latin typeface="Calibri"/>
               </a:rPr>
-              <a:t>The tool works. It should not be trusted blindly, and it does not need to be. It only has to point a tutor at the right student, early enough to matter.</a:t>
+              <a:t>The tool works, and it should not be trusted blindly, but it does not need to be, because it only has to point a tutor at the right student early enough to matter.</a:t>
             </a:r>
           </a:p>
         </p:txBody>
@@ -8010,7 +8010,7 @@
                 </a:solidFill>
                 <a:latin typeface="Calibri"/>
               </a:rPr>
-              <a:t>One dot is ten students. The filled ones do not graduate. The rate is 391 in 1,000 among the 3,630 whose outcome is settled, after setting aside 794 still enrolled.</a:t>
+              <a:t>Each dot is ten students, and the filled ones are the ones who do not graduate. The rate is 391 in every 1,000 among the 3,630 whose outcome is settled, once the 794 still enrolled are set aside.</a:t>
             </a:r>
           </a:p>
         </p:txBody>
@@ -8052,7 +8052,7 @@
                 </a:solidFill>
                 <a:latin typeface="Calibri"/>
               </a:rPr>
-              <a:t>Every one of them costs three things. The student loses the years and the fees. The school loses the tuition. The country loses a graduate it had already half paid for.</a:t>
+              <a:t>Every dropout costs three parties at once, because the student loses years and fees while the school loses tuition and the country loses a graduate it had already half paid for.</a:t>
             </a:r>
           </a:p>
           <a:p>
@@ -8071,7 +8071,7 @@
                 </a:solidFill>
                 <a:latin typeface="Calibri"/>
               </a:rPr>
-              <a:t>The school already knows this is happening. What it does not know is which students. It finds out when the first exam results come back. By then half the year is gone. And the student is usually gone too.</a:t>
+              <a:t>The school knows this is happening, and what it cannot see is which students, because that only becomes clear when the first exams come back, by which time half the year is gone and so, usually, is the student.</a:t>
             </a:r>
           </a:p>
         </p:txBody>
@@ -8152,7 +8152,7 @@
                 </a:solidFill>
                 <a:latin typeface="Calibri"/>
               </a:rPr>
-              <a:t>is the tuition one saved student pays back over a three year degree. A low estimate on purpose. The real loss to the student and the country is larger and harder to pin down. So it is left out.</a:t>
+              <a:t>the tuition that one saved student pays back over a three-year degree, which is a deliberately low estimate because the real loss is larger.</a:t>
             </a:r>
           </a:p>
         </p:txBody>
@@ -8194,7 +8194,7 @@
                 </a:solidFill>
                 <a:latin typeface="Calibri"/>
               </a:rPr>
-              <a:t>The question is not whether to help. It is who to help first, and when.</a:t>
+              <a:t>The question is not whether to help, but who to help first, and when.</a:t>
             </a:r>
           </a:p>
         </p:txBody>
@@ -8293,7 +8293,7 @@
                 </a:solidFill>
                 <a:latin typeface="Calibri"/>
               </a:rPr>
-              <a:t>It reads the enrollment form. Nothing else.</a:t>
+              <a:t>It reads the enrollment form, and nothing else.</a:t>
             </a:r>
           </a:p>
           <a:p>
@@ -8312,7 +8312,7 @@
                 </a:solidFill>
                 <a:latin typeface="Calibri"/>
               </a:rPr>
-              <a:t>Age. Course. How they applied. Whether they hold a scholarship. Whether the fees are paid. What their parents do. Everything on that list is known before the student sits in a single class.</a:t>
+              <a:t>It knows the student's age and course, whether they hold a scholarship, whether the fees are paid, and what a parent does, and all of it is known before the first class.</a:t>
             </a:r>
           </a:p>
           <a:p>
@@ -8350,7 +8350,7 @@
                 </a:solidFill>
                 <a:latin typeface="Calibri"/>
               </a:rPr>
-              <a:t>That was a deliberate choice and it costs accuracy. A tool that waits for first-term results would be far more certain. It would also be useless. By then the student has already decided.</a:t>
+              <a:t>That was on purpose and it costs some accuracy, because a tool that waited for first-term results would be more certain and also useless, since by then the student has already decided.</a:t>
             </a:r>
           </a:p>
           <a:p>
@@ -8388,7 +8388,7 @@
                 </a:solidFill>
                 <a:latin typeface="Calibri"/>
               </a:rPr>
-              <a:t>Most at risk at the top. Not a label. Not a verdict. Never a number shown to a student. A starting point for a conversation, twelve months early.</a:t>
+              <a:t>The students most at risk sit at the top, and it is a starting point for a conversation twelve months early rather than a number ever shown to a student.</a:t>
             </a:r>
           </a:p>
         </p:txBody>
@@ -8673,7 +8673,7 @@
                 </a:solidFill>
                 <a:latin typeface="Calibri"/>
               </a:rPr>
-              <a:t>The tool does not decide anything. It decides what a person looks at first.</a:t>
+              <a:t>The tool does not decide anything, and all it does is decide what a person looks at first.</a:t>
             </a:r>
           </a:p>
         </p:txBody>
@@ -9363,7 +9363,7 @@
                 </a:solidFill>
                 <a:latin typeface="Calibri"/>
               </a:rPr>
-              <a:t>Of the 391 who leave, the tool finds 311 of them.</a:t>
+              <a:t>Of the 391 who leave, the tool finds 311.</a:t>
             </a:r>
           </a:p>
           <a:p>
@@ -9382,7 +9382,7 @@
                 </a:solidFill>
                 <a:latin typeface="Calibri"/>
               </a:rPr>
-              <a:t>Eighty are missed. That is the honest number and it will not be zero. No tool that runs on an enrollment form finds everyone. A tool that claimed to would be lying.</a:t>
+              <a:t>Eighty are missed, which is the honest number and will never be zero, because no tool that runs on an enrollment form finds everyone.</a:t>
             </a:r>
           </a:p>
           <a:p>
@@ -9401,7 +9401,7 @@
                 </a:solidFill>
                 <a:latin typeface="Calibri"/>
               </a:rPr>
-              <a:t>The 172 is the number worth arguing about, and slide 6 argues about it.</a:t>
+              <a:t>The 172 contacted for nothing is the cost worth arguing about, and slide 6 does.</a:t>
             </a:r>
           </a:p>
         </p:txBody>
@@ -9482,7 +9482,7 @@
                 </a:solidFill>
                 <a:latin typeface="Calibri"/>
               </a:rPr>
-              <a:t>students the tool flags, roughly one in two. That is more than the tutoring team can staff, and the fairness fix on slide 8 is what brings the list back within reach.</a:t>
+              <a:t>students flagged, about one in two, which is more than the team can staff, and the fairness fix on slide 8 is what brings the list back within reach.</a:t>
             </a:r>
           </a:p>
         </p:txBody>
@@ -9705,7 +9705,7 @@
                 </a:solidFill>
                 <a:latin typeface="Calibri"/>
               </a:rPr>
-              <a:t>Three years of public tuition. Nothing else counted.</a:t>
+              <a:t>Three years of public tuition, and nothing else counted.</a:t>
             </a:r>
           </a:p>
           <a:p>
@@ -9743,7 +9743,7 @@
                 </a:solidFill>
                 <a:latin typeface="Calibri"/>
               </a:rPr>
-              <a:t>So a student the tool finds is worth about 630 EUR on average, not 2,100.</a:t>
+              <a:t>So a student the tool finds is worth about 630 EUR on average rather than 2,100.</a:t>
             </a:r>
           </a:p>
           <a:p>
@@ -9781,7 +9781,7 @@
                 </a:solidFill>
                 <a:latin typeface="Calibri"/>
               </a:rPr>
-              <a:t>The school knows this number. I do not. So all three are shown.</a:t>
+              <a:t>The school knows this number and I do not, so all three are shown.</a:t>
             </a:r>
           </a:p>
         </p:txBody>
@@ -10134,7 +10134,7 @@
                 </a:solidFill>
                 <a:latin typeface="Calibri"/>
               </a:rPr>
-              <a:t>Value per 1,000 students. Best case is the most profitable cutoff. At 1 in 2 is the cutoff the tool deploys at, and the gap between them at 150 EUR is only 1,700 EUR. So aiming the tool at the team's capacity is nearly free. Slide 8 is the thing that is not free.</a:t>
+              <a:t>Value per 1,000 students. Aiming at the team's capacity instead of the most profitable cutoff costs only about 1,700 EUR at a 150 EUR contact, so it is nearly free, and slide 8 is the thing that is not.</a:t>
             </a:r>
           </a:p>
         </p:txBody>
@@ -10176,7 +10176,7 @@
                 </a:solidFill>
                 <a:latin typeface="Calibri"/>
               </a:rPr>
-              <a:t>At 150 EUR a conversation, a save returns four times what a contact costs. The money says reach out broadly. There is barely any sorting left to do.</a:t>
+              <a:t>At 150 EUR a conversation, a save returns about four times what a contact costs, so the money says reach out broadly and there is barely any sorting left to do.</a:t>
             </a:r>
           </a:p>
         </p:txBody>
@@ -10802,7 +10802,7 @@
                 </a:solidFill>
                 <a:latin typeface="Calibri"/>
               </a:rPr>
-              <a:t>172 students in every 1,000 are contacted who were never going to leave.</a:t>
+              <a:t>172 in every 1,000 are contacted who were never going to leave.</a:t>
             </a:r>
           </a:p>
           <a:p>
@@ -10821,7 +10821,7 @@
                 </a:solidFill>
                 <a:latin typeface="Calibri"/>
               </a:rPr>
-              <a:t>That is the real cost of this tool and it is not paid in euros. It is paid by a student pulled into a help conversation they did not need. A student just told, in effect, that a system thinks they are failing.</a:t>
+              <a:t>The cost is not paid in euros but in a student pulled into a conversation they did not need, and told in effect that a system thinks they are failing.</a:t>
             </a:r>
           </a:p>
           <a:p>
@@ -10840,7 +10840,7 @@
                 </a:solidFill>
                 <a:latin typeface="Calibri"/>
               </a:rPr>
-              <a:t>The number can be driven down. Flag fewer students and fewer graduates get bothered. But every student cut from the list is also a leaver the team never reaches. And the 80 missed today becomes 120.</a:t>
+              <a:t>If the tool flags fewer students then fewer graduates get bothered, but every student it cuts is also a leaver the team never reaches, so the 80 missed today becomes 120.</a:t>
             </a:r>
           </a:p>
         </p:txBody>
@@ -10882,7 +10882,7 @@
                 </a:solidFill>
                 <a:latin typeface="Calibri"/>
               </a:rPr>
-              <a:t>This is the trade and it does not go away.</a:t>
+              <a:t>This is the trade, and it does not go away.</a:t>
             </a:r>
           </a:p>
           <a:p>
@@ -10901,7 +10901,7 @@
                 </a:solidFill>
                 <a:latin typeface="Calibri"/>
               </a:rPr>
-              <a:t>The tool cannot do both at once. Find more leavers and it bothers more graduates. Bother fewer graduates and it finds fewer leavers. Where the school sits is a judgement about students, not a calculation.</a:t>
+              <a:t>Finding more leavers always means bothering more graduates, and bothering fewer always means finding fewer, so where the school sits is a judgement about students rather than a calculation.</a:t>
             </a:r>
           </a:p>
         </p:txBody>
@@ -10943,7 +10943,7 @@
                 </a:solidFill>
                 <a:latin typeface="Calibri"/>
               </a:rPr>
-              <a:t>Which is why the list goes to a person, and the person decides who to call.</a:t>
+              <a:t>That is why the list goes to a person, and the person decides who to call.</a:t>
             </a:r>
           </a:p>
         </p:txBody>
@@ -11042,7 +11042,7 @@
                 </a:solidFill>
                 <a:latin typeface="Calibri"/>
               </a:rPr>
-              <a:t>The tool was checked across gender, age, scholarship, and debt. Gender is the one that fails on fairness. The other three flag groups that really do drop out more, though age still needs a closer look.</a:t>
+              <a:t>The tool was checked across gender, age, scholarship, and debt, and gender is the one that fails on fairness, because the other three flag groups that really do drop out more.</a:t>
             </a:r>
           </a:p>
         </p:txBody>
@@ -11402,7 +11402,7 @@
                 </a:solidFill>
                 <a:latin typeface="Calibri"/>
               </a:rPr>
-              <a:t>women who go on to drop out are never on the list at all. For men it is closer to one in eight.</a:t>
+              <a:t>of the women who go on to drop out are never on the list at all, and for men it is closer to one in eight.</a:t>
             </a:r>
           </a:p>
           <a:p>
@@ -11421,7 +11421,7 @@
                 </a:solidFill>
                 <a:latin typeface="Calibri"/>
               </a:rPr>
-              <a:t>This does not show up in any count of who gets flagged.</a:t>
+              <a:t>This shows up in no count of who gets flagged.</a:t>
             </a:r>
           </a:p>
           <a:p>
@@ -11440,7 +11440,7 @@
                 </a:solidFill>
                 <a:latin typeface="Calibri"/>
               </a:rPr>
-              <a:t>The tool flags men twice as often as women. So a check on flagging rates says men are over-contacted and stops there. That check is not wrong. It just answers a different question.</a:t>
+              <a:t>The tool flags men about twice as often as women, so a check on flagging rates says men are over-contacted and stops there, which answers a different question from the one that matters.</a:t>
             </a:r>
           </a:p>
           <a:p>
@@ -11459,7 +11459,7 @@
                 </a:solidFill>
                 <a:latin typeface="Calibri"/>
               </a:rPr>
-              <a:t>The harm only appears when you stop counting who gets contacted and start counting who gets missed.</a:t>
+              <a:t>The harm only appears when you count who gets missed rather than who gets contacted.</a:t>
             </a:r>
           </a:p>
         </p:txBody>
@@ -11501,7 +11501,7 @@
                 </a:solidFill>
                 <a:latin typeface="Calibri"/>
               </a:rPr>
-              <a:t>The students this tool exists to reach are being missed. And they are being missed unevenly.</a:t>
+              <a:t>The students this tool exists to reach are being missed, and they are being missed unevenly.</a:t>
             </a:r>
           </a:p>
         </p:txBody>
@@ -11937,7 +11937,7 @@
                 </a:solidFill>
                 <a:latin typeface="Calibri"/>
               </a:rPr>
-              <a:t>That is a real cost and it should be written down plainly, not buried in an appendix. Thirty students who would have been caught now will not be. In money that is about 8,000 EUR per 1,000 students at a 150 EUR contact, and the catch rate falls from about 8 in 10 to 7 in 10.</a:t>
+              <a:t>That is about 8,000 EUR per 1,000 students at a 150 EUR contact, and the catch rate falls from about 8 in 10 to 7 in 10.</a:t>
             </a:r>
           </a:p>
           <a:p>
@@ -11975,9 +11975,71 @@
                 </a:solidFill>
                 <a:latin typeface="Calibri"/>
               </a:rPr>
-              <a:t>The correction does not make the tool better. It makes it evenly bad.</a:t>
-            </a:r>
-          </a:p>
+              <a:t>It does not make the tool better but it makes it evenly bad, and the list of about 410 still fits what the team can reach.</a:t>
+            </a:r>
+          </a:p>
+        </p:txBody>
+      </p:sp>
+      <p:sp>
+        <p:nvSpPr>
+          <p:cNvPr id="12" name="TextBox 11"/>
+          <p:cNvSpPr txBox="1"/>
+          <p:nvPr/>
+        </p:nvSpPr>
+        <p:spPr>
+          <a:xfrm>
+            <a:off x="7223760" y="1874519"/>
+            <a:ext cx="4389120" cy="365760"/>
+          </a:xfrm>
+          <a:prstGeom prst="rect">
+            <a:avLst/>
+          </a:prstGeom>
+          <a:noFill/>
+        </p:spPr>
+        <p:txBody>
+          <a:bodyPr wrap="square" lIns="0" rIns="0" tIns="0" bIns="0">
+            <a:spAutoFit/>
+          </a:bodyPr>
+          <a:lstStyle/>
+          <a:p>
+            <a:pPr algn="l">
+              <a:spcAft>
+                <a:spcPts val="600"/>
+              </a:spcAft>
+            </a:pPr>
+            <a:r>
+              <a:rPr sz="1200" b="1">
+                <a:solidFill>
+                  <a:srgbClr val="1A1A1A"/>
+                </a:solidFill>
+                <a:latin typeface="Calibri"/>
+              </a:rPr>
+              <a:t>The option the school should not take</a:t>
+            </a:r>
+          </a:p>
+        </p:txBody>
+      </p:sp>
+      <p:sp>
+        <p:nvSpPr>
+          <p:cNvPr id="13" name="TextBox 12"/>
+          <p:cNvSpPr txBox="1"/>
+          <p:nvPr/>
+        </p:nvSpPr>
+        <p:spPr>
+          <a:xfrm>
+            <a:off x="7223760" y="2286000"/>
+            <a:ext cx="4389120" cy="2103120"/>
+          </a:xfrm>
+          <a:prstGeom prst="rect">
+            <a:avLst/>
+          </a:prstGeom>
+          <a:noFill/>
+        </p:spPr>
+        <p:txBody>
+          <a:bodyPr wrap="square" lIns="0" rIns="0" tIns="0" bIns="0">
+            <a:spAutoFit/>
+          </a:bodyPr>
+          <a:lstStyle/>
           <a:p>
             <a:pPr algn="l">
               <a:lnSpc>
@@ -11994,71 +12056,9 @@
                 </a:solidFill>
                 <a:latin typeface="Calibri"/>
               </a:rPr>
-              <a:t>The list of about 410 fits what the team can reach, so everyone on it is contacted.</a:t>
-            </a:r>
-          </a:p>
-        </p:txBody>
-      </p:sp>
-      <p:sp>
-        <p:nvSpPr>
-          <p:cNvPr id="12" name="TextBox 11"/>
-          <p:cNvSpPr txBox="1"/>
-          <p:nvPr/>
-        </p:nvSpPr>
-        <p:spPr>
-          <a:xfrm>
-            <a:off x="7223760" y="1874519"/>
-            <a:ext cx="4389120" cy="365760"/>
-          </a:xfrm>
-          <a:prstGeom prst="rect">
-            <a:avLst/>
-          </a:prstGeom>
-          <a:noFill/>
-        </p:spPr>
-        <p:txBody>
-          <a:bodyPr wrap="square" lIns="0" rIns="0" tIns="0" bIns="0">
-            <a:spAutoFit/>
-          </a:bodyPr>
-          <a:lstStyle/>
-          <a:p>
-            <a:pPr algn="l">
-              <a:spcAft>
-                <a:spcPts val="600"/>
-              </a:spcAft>
-            </a:pPr>
-            <a:r>
-              <a:rPr sz="1200" b="1">
-                <a:solidFill>
-                  <a:srgbClr val="1A1A1A"/>
-                </a:solidFill>
-                <a:latin typeface="Calibri"/>
-              </a:rPr>
-              <a:t>The option the school should not take</a:t>
-            </a:r>
-          </a:p>
-        </p:txBody>
-      </p:sp>
-      <p:sp>
-        <p:nvSpPr>
-          <p:cNvPr id="13" name="TextBox 12"/>
-          <p:cNvSpPr txBox="1"/>
-          <p:nvPr/>
-        </p:nvSpPr>
-        <p:spPr>
-          <a:xfrm>
-            <a:off x="7223760" y="2286000"/>
-            <a:ext cx="4389120" cy="2103120"/>
-          </a:xfrm>
-          <a:prstGeom prst="rect">
-            <a:avLst/>
-          </a:prstGeom>
-          <a:noFill/>
-        </p:spPr>
-        <p:txBody>
-          <a:bodyPr wrap="square" lIns="0" rIns="0" tIns="0" bIns="0">
-            <a:spAutoFit/>
-          </a:bodyPr>
-          <a:lstStyle/>
+              <a:t>A second fix closes the same gap and looks better on paper, but it gets there by contacting fewer students of every kind, so it costs seventy leavers instead of thirty.</a:t>
+            </a:r>
+          </a:p>
           <a:p>
             <a:pPr algn="l">
               <a:lnSpc>
@@ -12069,15 +12069,38 @@
               </a:spcAft>
             </a:pPr>
             <a:r>
-              <a:rPr sz="1300" b="0">
-                <a:solidFill>
-                  <a:srgbClr val="595959"/>
+              <a:rPr sz="1300" b="1">
+                <a:solidFill>
+                  <a:srgbClr val="1A1A1A"/>
                 </a:solidFill>
                 <a:latin typeface="Calibri"/>
               </a:rPr>
-              <a:t>A second correction closes the same gap and looks better on paper. Overall accuracy goes up.</a:t>
-            </a:r>
-          </a:p>
+              <a:t>Fixing a gap by helping fewer people is not a fix.</a:t>
+            </a:r>
+          </a:p>
+        </p:txBody>
+      </p:sp>
+      <p:sp>
+        <p:nvSpPr>
+          <p:cNvPr id="14" name="TextBox 13"/>
+          <p:cNvSpPr txBox="1"/>
+          <p:nvPr/>
+        </p:nvSpPr>
+        <p:spPr>
+          <a:xfrm>
+            <a:off x="7223760" y="4709160"/>
+            <a:ext cx="4389120" cy="1280160"/>
+          </a:xfrm>
+          <a:prstGeom prst="rect">
+            <a:avLst/>
+          </a:prstGeom>
+          <a:noFill/>
+        </p:spPr>
+        <p:txBody>
+          <a:bodyPr wrap="square" lIns="0" rIns="0" tIns="0" bIns="0">
+            <a:spAutoFit/>
+          </a:bodyPr>
+          <a:lstStyle/>
           <a:p>
             <a:pPr algn="l">
               <a:lnSpc>
@@ -12088,13 +12111,13 @@
               </a:spcAft>
             </a:pPr>
             <a:r>
-              <a:rPr sz="1300" b="0">
-                <a:solidFill>
-                  <a:srgbClr val="595959"/>
+              <a:rPr sz="1300" b="1">
+                <a:solidFill>
+                  <a:srgbClr val="1A1A1A"/>
                 </a:solidFill>
                 <a:latin typeface="Calibri"/>
               </a:rPr>
-              <a:t>It gets there by contacting fewer students of every kind. It closes the gap by helping fewer people. And it costs seventy fewer leavers found instead of thirty.</a:t>
+              <a:t>This is the school's decision, not the tool's.</a:t>
             </a:r>
           </a:p>
           <a:p>
@@ -12107,74 +12130,13 @@
               </a:spcAft>
             </a:pPr>
             <a:r>
-              <a:rPr sz="1300" b="1">
-                <a:solidFill>
-                  <a:srgbClr val="1A1A1A"/>
+              <a:rPr sz="1300" b="0">
+                <a:solidFill>
+                  <a:srgbClr val="595959"/>
                 </a:solidFill>
                 <a:latin typeface="Calibri"/>
               </a:rPr>
-              <a:t>Fixing a gap by helping fewer people is not a fix.</a:t>
-            </a:r>
-          </a:p>
-        </p:txBody>
-      </p:sp>
-      <p:sp>
-        <p:nvSpPr>
-          <p:cNvPr id="14" name="TextBox 13"/>
-          <p:cNvSpPr txBox="1"/>
-          <p:nvPr/>
-        </p:nvSpPr>
-        <p:spPr>
-          <a:xfrm>
-            <a:off x="7223760" y="4709160"/>
-            <a:ext cx="4389120" cy="1280160"/>
-          </a:xfrm>
-          <a:prstGeom prst="rect">
-            <a:avLst/>
-          </a:prstGeom>
-          <a:noFill/>
-        </p:spPr>
-        <p:txBody>
-          <a:bodyPr wrap="square" lIns="0" rIns="0" tIns="0" bIns="0">
-            <a:spAutoFit/>
-          </a:bodyPr>
-          <a:lstStyle/>
-          <a:p>
-            <a:pPr algn="l">
-              <a:lnSpc>
-                <a:spcPct val="125000"/>
-              </a:lnSpc>
-              <a:spcAft>
-                <a:spcPts val="800"/>
-              </a:spcAft>
-            </a:pPr>
-            <a:r>
-              <a:rPr sz="1300" b="1">
-                <a:solidFill>
-                  <a:srgbClr val="1A1A1A"/>
-                </a:solidFill>
-                <a:latin typeface="Calibri"/>
-              </a:rPr>
-              <a:t>This is the school's decision, not the tool's.</a:t>
-            </a:r>
-          </a:p>
-          <a:p>
-            <a:pPr algn="l">
-              <a:lnSpc>
-                <a:spcPct val="125000"/>
-              </a:lnSpc>
-              <a:spcAft>
-                <a:spcPts val="800"/>
-              </a:spcAft>
-            </a:pPr>
-            <a:r>
-              <a:rPr sz="1300" b="0">
-                <a:solidFill>
-                  <a:srgbClr val="595959"/>
-                </a:solidFill>
-                <a:latin typeface="Calibri"/>
-              </a:rPr>
-              <a:t>Thirty students is the price of the tool being as good at finding women as it is at finding men. Nobody but the school can say whether that is worth paying.</a:t>
+              <a:t>Thirty students is the price of the tool finding women as well as it finds men, and only the school can say whether that is worth paying.</a:t>
             </a:r>
           </a:p>
         </p:txBody>
@@ -12216,7 +12178,7 @@
                 </a:solidFill>
                 <a:latin typeface="Calibri"/>
               </a:rPr>
-              <a:t>The recommendation is to pay it. But the number is on the table, not hidden.</a:t>
+              <a:t>The recommendation is to pay it, but the number is on the table rather than hidden.</a:t>
             </a:r>
           </a:p>
         </p:txBody>
@@ -12477,8 +12439,8 @@
                 </a:solidFill>
                 <a:latin typeface="Calibri"/>
               </a:rPr>
-              <a:t>The tool produces its list. Nobody is contacted. At the end of term, compare who it flagged against who actually left. And against who the tutors would have worried about anyway.
-If it does not beat the tutors, it does not deploy.</a:t>
+              <a:t>The tool produces its list and nobody is contacted, and at the end of term the school compares who it flagged against who actually left, and against who the tutors would have worried about anyway.
+If it does not beat the tutors then it does not deploy.</a:t>
             </a:r>
           </a:p>
         </p:txBody>
@@ -12643,8 +12605,8 @@
                 </a:solidFill>
                 <a:latin typeface="Calibri"/>
               </a:rPr>
-              <a:t>A single department runs it for real. The list goes to a tutor. The tutor decides who to call.
-This measures the thing nobody has measured yet. Whether reaching out actually keeps anyone. Every number on slide 5 rests on an assumption of three in ten. This is where that gets checked.</a:t>
+              <a:t>A single department runs it for real, and the list goes to a tutor who decides who to call.
+This finally tests the thing slide 5 rests on, which is whether reaching out actually keeps anyone, since that was only ever an assumption of three in ten.</a:t>
             </a:r>
           </a:p>
         </p:txBody>
@@ -12809,8 +12771,8 @@
                 </a:solidFill>
                 <a:latin typeface="Calibri"/>
               </a:rPr>
-              <a:t>School-wide, with the gender gap re-measured at every intake and reported to whoever owns this decision.
-The gap was measured on one group of 130 women who left. It is not the kind of thing that stays fixed on its own.</a:t>
+              <a:t>The tool runs school-wide, with the gender gap re-measured at every intake and reported to whoever owns the decision.
+It was measured on a single group of 130 women, and it will not stay fixed on its own.</a:t>
             </a:r>
           </a:p>
         </p:txBody>
@@ -12852,7 +12814,7 @@
                 </a:solidFill>
                 <a:latin typeface="Calibri"/>
               </a:rPr>
-              <a:t>The tool is cheap to run and expensive to trust. So buy the trust in stages.</a:t>
+              <a:t>The tool is cheap to run and expensive to trust, so the school buys that trust in stages.</a:t>
             </a:r>
           </a:p>
         </p:txBody>

</xml_diff>

<commit_message>
fix: fix the decks
</commit_message>
<xml_diff>
--- a/presentations/business.pptx
+++ b/presentations/business.pptx
@@ -5,18 +5,18 @@
     <p:sldMasterId id="2147483648" r:id="rId1"/>
   </p:sldMasterIdLst>
   <p:sldIdLst>
-    <p:sldId id="256" r:id="rId7"/>
-    <p:sldId id="257" r:id="rId8"/>
-    <p:sldId id="258" r:id="rId9"/>
-    <p:sldId id="259" r:id="rId10"/>
-    <p:sldId id="260" r:id="rId11"/>
-    <p:sldId id="261" r:id="rId12"/>
-    <p:sldId id="262" r:id="rId13"/>
-    <p:sldId id="263" r:id="rId14"/>
-    <p:sldId id="264" r:id="rId15"/>
-    <p:sldId id="265" r:id="rId16"/>
+    <p:sldId id="256" r:id="rId2"/>
+    <p:sldId id="257" r:id="rId3"/>
+    <p:sldId id="258" r:id="rId4"/>
+    <p:sldId id="259" r:id="rId5"/>
+    <p:sldId id="260" r:id="rId6"/>
+    <p:sldId id="261" r:id="rId7"/>
+    <p:sldId id="262" r:id="rId8"/>
+    <p:sldId id="263" r:id="rId9"/>
+    <p:sldId id="264" r:id="rId10"/>
+    <p:sldId id="265" r:id="rId11"/>
   </p:sldIdLst>
-  <p:sldSz cx="12191695" cy="6858000" type="screen4x3"/>
+  <p:sldSz cx="12192000" cy="6858000"/>
   <p:notesSz cx="6858000" cy="9144000"/>
   <p:defaultTextStyle>
     <a:defPPr>
@@ -113,6 +113,22 @@
       </a:defRPr>
     </a:lvl9pPr>
   </p:defaultTextStyle>
+  <p:extLst>
+    <p:ext uri="{EFAFB233-063F-42B5-8137-9DF3F51BA10A}">
+      <p15:sldGuideLst xmlns:p15="http://schemas.microsoft.com/office/powerpoint/2012/main">
+        <p15:guide id="1" orient="horz" pos="2160">
+          <p15:clr>
+            <a:srgbClr val="A4A3A4"/>
+          </p15:clr>
+        </p15:guide>
+        <p15:guide id="2" pos="2880">
+          <p15:clr>
+            <a:srgbClr val="A4A3A4"/>
+          </p15:clr>
+        </p15:guide>
+      </p15:sldGuideLst>
+    </p:ext>
+  </p:extLst>
 </p:presentation>
 </file>
 
@@ -154,10 +170,9 @@
           <a:lstStyle/>
           <a:p>
             <a:r>
-              <a:rPr lang="en-US" smtClean="0"/>
+              <a:rPr lang="en-US"/>
               <a:t>Click to edit Master title style</a:t>
             </a:r>
-            <a:endParaRPr lang="en-US"/>
           </a:p>
         </p:txBody>
       </p:sp>
@@ -273,10 +288,9 @@
           </a:lstStyle>
           <a:p>
             <a:r>
-              <a:rPr lang="en-US" smtClean="0"/>
+              <a:rPr lang="en-US"/>
               <a:t>Click to edit Master subtitle style</a:t>
             </a:r>
-            <a:endParaRPr lang="en-US"/>
           </a:p>
         </p:txBody>
       </p:sp>
@@ -297,7 +311,7 @@
           <a:p>
             <a:fld id="{5BCAD085-E8A6-8845-BD4E-CB4CCA059FC4}" type="datetimeFigureOut">
               <a:rPr lang="en-US" smtClean="0"/>
-              <a:t>1/27/13</a:t>
+              <a:t>7/17/26</a:t>
             </a:fld>
             <a:endParaRPr lang="en-US"/>
           </a:p>
@@ -391,10 +405,9 @@
           <a:lstStyle/>
           <a:p>
             <a:r>
-              <a:rPr lang="en-US" smtClean="0"/>
+              <a:rPr lang="en-US"/>
               <a:t>Click to edit Master title style</a:t>
             </a:r>
-            <a:endParaRPr lang="en-US"/>
           </a:p>
         </p:txBody>
       </p:sp>
@@ -415,38 +428,37 @@
           <a:p>
             <a:pPr lvl="0"/>
             <a:r>
-              <a:rPr lang="en-US" smtClean="0"/>
+              <a:rPr lang="en-US"/>
               <a:t>Click to edit Master text styles</a:t>
             </a:r>
           </a:p>
           <a:p>
             <a:pPr lvl="1"/>
             <a:r>
-              <a:rPr lang="en-US" smtClean="0"/>
+              <a:rPr lang="en-US"/>
               <a:t>Second level</a:t>
             </a:r>
           </a:p>
           <a:p>
             <a:pPr lvl="2"/>
             <a:r>
-              <a:rPr lang="en-US" smtClean="0"/>
+              <a:rPr lang="en-US"/>
               <a:t>Third level</a:t>
             </a:r>
           </a:p>
           <a:p>
             <a:pPr lvl="3"/>
             <a:r>
-              <a:rPr lang="en-US" smtClean="0"/>
+              <a:rPr lang="en-US"/>
               <a:t>Fourth level</a:t>
             </a:r>
           </a:p>
           <a:p>
             <a:pPr lvl="4"/>
             <a:r>
-              <a:rPr lang="en-US" smtClean="0"/>
+              <a:rPr lang="en-US"/>
               <a:t>Fifth level</a:t>
             </a:r>
-            <a:endParaRPr lang="en-US"/>
           </a:p>
         </p:txBody>
       </p:sp>
@@ -467,7 +479,7 @@
           <a:p>
             <a:fld id="{5BCAD085-E8A6-8845-BD4E-CB4CCA059FC4}" type="datetimeFigureOut">
               <a:rPr lang="en-US" smtClean="0"/>
-              <a:t>1/27/13</a:t>
+              <a:t>7/17/26</a:t>
             </a:fld>
             <a:endParaRPr lang="en-US"/>
           </a:p>
@@ -566,10 +578,9 @@
           <a:lstStyle/>
           <a:p>
             <a:r>
-              <a:rPr lang="en-US" smtClean="0"/>
+              <a:rPr lang="en-US"/>
               <a:t>Click to edit Master title style</a:t>
             </a:r>
-            <a:endParaRPr lang="en-US"/>
           </a:p>
         </p:txBody>
       </p:sp>
@@ -595,38 +606,37 @@
           <a:p>
             <a:pPr lvl="0"/>
             <a:r>
-              <a:rPr lang="en-US" smtClean="0"/>
+              <a:rPr lang="en-US"/>
               <a:t>Click to edit Master text styles</a:t>
             </a:r>
           </a:p>
           <a:p>
             <a:pPr lvl="1"/>
             <a:r>
-              <a:rPr lang="en-US" smtClean="0"/>
+              <a:rPr lang="en-US"/>
               <a:t>Second level</a:t>
             </a:r>
           </a:p>
           <a:p>
             <a:pPr lvl="2"/>
             <a:r>
-              <a:rPr lang="en-US" smtClean="0"/>
+              <a:rPr lang="en-US"/>
               <a:t>Third level</a:t>
             </a:r>
           </a:p>
           <a:p>
             <a:pPr lvl="3"/>
             <a:r>
-              <a:rPr lang="en-US" smtClean="0"/>
+              <a:rPr lang="en-US"/>
               <a:t>Fourth level</a:t>
             </a:r>
           </a:p>
           <a:p>
             <a:pPr lvl="4"/>
             <a:r>
-              <a:rPr lang="en-US" smtClean="0"/>
+              <a:rPr lang="en-US"/>
               <a:t>Fifth level</a:t>
             </a:r>
-            <a:endParaRPr lang="en-US"/>
           </a:p>
         </p:txBody>
       </p:sp>
@@ -647,7 +657,7 @@
           <a:p>
             <a:fld id="{5BCAD085-E8A6-8845-BD4E-CB4CCA059FC4}" type="datetimeFigureOut">
               <a:rPr lang="en-US" smtClean="0"/>
-              <a:t>1/27/13</a:t>
+              <a:t>7/17/26</a:t>
             </a:fld>
             <a:endParaRPr lang="en-US"/>
           </a:p>
@@ -741,10 +751,9 @@
           <a:lstStyle/>
           <a:p>
             <a:r>
-              <a:rPr lang="en-US" smtClean="0"/>
+              <a:rPr lang="en-US"/>
               <a:t>Click to edit Master title style</a:t>
             </a:r>
-            <a:endParaRPr lang="en-US"/>
           </a:p>
         </p:txBody>
       </p:sp>
@@ -765,38 +774,37 @@
           <a:p>
             <a:pPr lvl="0"/>
             <a:r>
-              <a:rPr lang="en-US" smtClean="0"/>
+              <a:rPr lang="en-US"/>
               <a:t>Click to edit Master text styles</a:t>
             </a:r>
           </a:p>
           <a:p>
             <a:pPr lvl="1"/>
             <a:r>
-              <a:rPr lang="en-US" smtClean="0"/>
+              <a:rPr lang="en-US"/>
               <a:t>Second level</a:t>
             </a:r>
           </a:p>
           <a:p>
             <a:pPr lvl="2"/>
             <a:r>
-              <a:rPr lang="en-US" smtClean="0"/>
+              <a:rPr lang="en-US"/>
               <a:t>Third level</a:t>
             </a:r>
           </a:p>
           <a:p>
             <a:pPr lvl="3"/>
             <a:r>
-              <a:rPr lang="en-US" smtClean="0"/>
+              <a:rPr lang="en-US"/>
               <a:t>Fourth level</a:t>
             </a:r>
           </a:p>
           <a:p>
             <a:pPr lvl="4"/>
             <a:r>
-              <a:rPr lang="en-US" smtClean="0"/>
+              <a:rPr lang="en-US"/>
               <a:t>Fifth level</a:t>
             </a:r>
-            <a:endParaRPr lang="en-US"/>
           </a:p>
         </p:txBody>
       </p:sp>
@@ -817,7 +825,7 @@
           <a:p>
             <a:fld id="{5BCAD085-E8A6-8845-BD4E-CB4CCA059FC4}" type="datetimeFigureOut">
               <a:rPr lang="en-US" smtClean="0"/>
-              <a:t>1/27/13</a:t>
+              <a:t>7/17/26</a:t>
             </a:fld>
             <a:endParaRPr lang="en-US"/>
           </a:p>
@@ -920,10 +928,9 @@
           </a:lstStyle>
           <a:p>
             <a:r>
-              <a:rPr lang="en-US" smtClean="0"/>
+              <a:rPr lang="en-US"/>
               <a:t>Click to edit Master title style</a:t>
             </a:r>
-            <a:endParaRPr lang="en-US"/>
           </a:p>
         </p:txBody>
       </p:sp>
@@ -1040,7 +1047,7 @@
           <a:p>
             <a:pPr lvl="0"/>
             <a:r>
-              <a:rPr lang="en-US" smtClean="0"/>
+              <a:rPr lang="en-US"/>
               <a:t>Click to edit Master text styles</a:t>
             </a:r>
           </a:p>
@@ -1063,7 +1070,7 @@
           <a:p>
             <a:fld id="{5BCAD085-E8A6-8845-BD4E-CB4CCA059FC4}" type="datetimeFigureOut">
               <a:rPr lang="en-US" smtClean="0"/>
-              <a:t>1/27/13</a:t>
+              <a:t>7/17/26</a:t>
             </a:fld>
             <a:endParaRPr lang="en-US"/>
           </a:p>
@@ -1157,10 +1164,9 @@
           <a:lstStyle/>
           <a:p>
             <a:r>
-              <a:rPr lang="en-US" smtClean="0"/>
+              <a:rPr lang="en-US"/>
               <a:t>Click to edit Master title style</a:t>
             </a:r>
-            <a:endParaRPr lang="en-US"/>
           </a:p>
         </p:txBody>
       </p:sp>
@@ -1214,38 +1220,37 @@
           <a:p>
             <a:pPr lvl="0"/>
             <a:r>
-              <a:rPr lang="en-US" smtClean="0"/>
+              <a:rPr lang="en-US"/>
               <a:t>Click to edit Master text styles</a:t>
             </a:r>
           </a:p>
           <a:p>
             <a:pPr lvl="1"/>
             <a:r>
-              <a:rPr lang="en-US" smtClean="0"/>
+              <a:rPr lang="en-US"/>
               <a:t>Second level</a:t>
             </a:r>
           </a:p>
           <a:p>
             <a:pPr lvl="2"/>
             <a:r>
-              <a:rPr lang="en-US" smtClean="0"/>
+              <a:rPr lang="en-US"/>
               <a:t>Third level</a:t>
             </a:r>
           </a:p>
           <a:p>
             <a:pPr lvl="3"/>
             <a:r>
-              <a:rPr lang="en-US" smtClean="0"/>
+              <a:rPr lang="en-US"/>
               <a:t>Fourth level</a:t>
             </a:r>
           </a:p>
           <a:p>
             <a:pPr lvl="4"/>
             <a:r>
-              <a:rPr lang="en-US" smtClean="0"/>
+              <a:rPr lang="en-US"/>
               <a:t>Fifth level</a:t>
             </a:r>
-            <a:endParaRPr lang="en-US"/>
           </a:p>
         </p:txBody>
       </p:sp>
@@ -1299,38 +1304,37 @@
           <a:p>
             <a:pPr lvl="0"/>
             <a:r>
-              <a:rPr lang="en-US" smtClean="0"/>
+              <a:rPr lang="en-US"/>
               <a:t>Click to edit Master text styles</a:t>
             </a:r>
           </a:p>
           <a:p>
             <a:pPr lvl="1"/>
             <a:r>
-              <a:rPr lang="en-US" smtClean="0"/>
+              <a:rPr lang="en-US"/>
               <a:t>Second level</a:t>
             </a:r>
           </a:p>
           <a:p>
             <a:pPr lvl="2"/>
             <a:r>
-              <a:rPr lang="en-US" smtClean="0"/>
+              <a:rPr lang="en-US"/>
               <a:t>Third level</a:t>
             </a:r>
           </a:p>
           <a:p>
             <a:pPr lvl="3"/>
             <a:r>
-              <a:rPr lang="en-US" smtClean="0"/>
+              <a:rPr lang="en-US"/>
               <a:t>Fourth level</a:t>
             </a:r>
           </a:p>
           <a:p>
             <a:pPr lvl="4"/>
             <a:r>
-              <a:rPr lang="en-US" smtClean="0"/>
+              <a:rPr lang="en-US"/>
               <a:t>Fifth level</a:t>
             </a:r>
-            <a:endParaRPr lang="en-US"/>
           </a:p>
         </p:txBody>
       </p:sp>
@@ -1351,7 +1355,7 @@
           <a:p>
             <a:fld id="{5BCAD085-E8A6-8845-BD4E-CB4CCA059FC4}" type="datetimeFigureOut">
               <a:rPr lang="en-US" smtClean="0"/>
-              <a:t>1/27/13</a:t>
+              <a:t>7/17/26</a:t>
             </a:fld>
             <a:endParaRPr lang="en-US"/>
           </a:p>
@@ -1449,10 +1453,9 @@
           </a:lstStyle>
           <a:p>
             <a:r>
-              <a:rPr lang="en-US" smtClean="0"/>
+              <a:rPr lang="en-US"/>
               <a:t>Click to edit Master title style</a:t>
             </a:r>
-            <a:endParaRPr lang="en-US"/>
           </a:p>
         </p:txBody>
       </p:sp>
@@ -1515,7 +1518,7 @@
           <a:p>
             <a:pPr lvl="0"/>
             <a:r>
-              <a:rPr lang="en-US" smtClean="0"/>
+              <a:rPr lang="en-US"/>
               <a:t>Click to edit Master text styles</a:t>
             </a:r>
           </a:p>
@@ -1571,38 +1574,37 @@
           <a:p>
             <a:pPr lvl="0"/>
             <a:r>
-              <a:rPr lang="en-US" smtClean="0"/>
+              <a:rPr lang="en-US"/>
               <a:t>Click to edit Master text styles</a:t>
             </a:r>
           </a:p>
           <a:p>
             <a:pPr lvl="1"/>
             <a:r>
-              <a:rPr lang="en-US" smtClean="0"/>
+              <a:rPr lang="en-US"/>
               <a:t>Second level</a:t>
             </a:r>
           </a:p>
           <a:p>
             <a:pPr lvl="2"/>
             <a:r>
-              <a:rPr lang="en-US" smtClean="0"/>
+              <a:rPr lang="en-US"/>
               <a:t>Third level</a:t>
             </a:r>
           </a:p>
           <a:p>
             <a:pPr lvl="3"/>
             <a:r>
-              <a:rPr lang="en-US" smtClean="0"/>
+              <a:rPr lang="en-US"/>
               <a:t>Fourth level</a:t>
             </a:r>
           </a:p>
           <a:p>
             <a:pPr lvl="4"/>
             <a:r>
-              <a:rPr lang="en-US" smtClean="0"/>
+              <a:rPr lang="en-US"/>
               <a:t>Fifth level</a:t>
             </a:r>
-            <a:endParaRPr lang="en-US"/>
           </a:p>
         </p:txBody>
       </p:sp>
@@ -1665,7 +1667,7 @@
           <a:p>
             <a:pPr lvl="0"/>
             <a:r>
-              <a:rPr lang="en-US" smtClean="0"/>
+              <a:rPr lang="en-US"/>
               <a:t>Click to edit Master text styles</a:t>
             </a:r>
           </a:p>
@@ -1721,38 +1723,37 @@
           <a:p>
             <a:pPr lvl="0"/>
             <a:r>
-              <a:rPr lang="en-US" smtClean="0"/>
+              <a:rPr lang="en-US"/>
               <a:t>Click to edit Master text styles</a:t>
             </a:r>
           </a:p>
           <a:p>
             <a:pPr lvl="1"/>
             <a:r>
-              <a:rPr lang="en-US" smtClean="0"/>
+              <a:rPr lang="en-US"/>
               <a:t>Second level</a:t>
             </a:r>
           </a:p>
           <a:p>
             <a:pPr lvl="2"/>
             <a:r>
-              <a:rPr lang="en-US" smtClean="0"/>
+              <a:rPr lang="en-US"/>
               <a:t>Third level</a:t>
             </a:r>
           </a:p>
           <a:p>
             <a:pPr lvl="3"/>
             <a:r>
-              <a:rPr lang="en-US" smtClean="0"/>
+              <a:rPr lang="en-US"/>
               <a:t>Fourth level</a:t>
             </a:r>
           </a:p>
           <a:p>
             <a:pPr lvl="4"/>
             <a:r>
-              <a:rPr lang="en-US" smtClean="0"/>
+              <a:rPr lang="en-US"/>
               <a:t>Fifth level</a:t>
             </a:r>
-            <a:endParaRPr lang="en-US"/>
           </a:p>
         </p:txBody>
       </p:sp>
@@ -1773,7 +1774,7 @@
           <a:p>
             <a:fld id="{5BCAD085-E8A6-8845-BD4E-CB4CCA059FC4}" type="datetimeFigureOut">
               <a:rPr lang="en-US" smtClean="0"/>
-              <a:t>1/27/13</a:t>
+              <a:t>7/17/26</a:t>
             </a:fld>
             <a:endParaRPr lang="en-US"/>
           </a:p>
@@ -1867,10 +1868,9 @@
           <a:lstStyle/>
           <a:p>
             <a:r>
-              <a:rPr lang="en-US" smtClean="0"/>
+              <a:rPr lang="en-US"/>
               <a:t>Click to edit Master title style</a:t>
             </a:r>
-            <a:endParaRPr lang="en-US"/>
           </a:p>
         </p:txBody>
       </p:sp>
@@ -1891,7 +1891,7 @@
           <a:p>
             <a:fld id="{5BCAD085-E8A6-8845-BD4E-CB4CCA059FC4}" type="datetimeFigureOut">
               <a:rPr lang="en-US" smtClean="0"/>
-              <a:t>1/27/13</a:t>
+              <a:t>7/17/26</a:t>
             </a:fld>
             <a:endParaRPr lang="en-US"/>
           </a:p>
@@ -1986,7 +1986,7 @@
           <a:p>
             <a:fld id="{5BCAD085-E8A6-8845-BD4E-CB4CCA059FC4}" type="datetimeFigureOut">
               <a:rPr lang="en-US" smtClean="0"/>
-              <a:t>1/27/13</a:t>
+              <a:t>7/17/26</a:t>
             </a:fld>
             <a:endParaRPr lang="en-US"/>
           </a:p>
@@ -2089,10 +2089,9 @@
           </a:lstStyle>
           <a:p>
             <a:r>
-              <a:rPr lang="en-US" smtClean="0"/>
+              <a:rPr lang="en-US"/>
               <a:t>Click to edit Master title style</a:t>
             </a:r>
-            <a:endParaRPr lang="en-US"/>
           </a:p>
         </p:txBody>
       </p:sp>
@@ -2146,38 +2145,37 @@
           <a:p>
             <a:pPr lvl="0"/>
             <a:r>
-              <a:rPr lang="en-US" smtClean="0"/>
+              <a:rPr lang="en-US"/>
               <a:t>Click to edit Master text styles</a:t>
             </a:r>
           </a:p>
           <a:p>
             <a:pPr lvl="1"/>
             <a:r>
-              <a:rPr lang="en-US" smtClean="0"/>
+              <a:rPr lang="en-US"/>
               <a:t>Second level</a:t>
             </a:r>
           </a:p>
           <a:p>
             <a:pPr lvl="2"/>
             <a:r>
-              <a:rPr lang="en-US" smtClean="0"/>
+              <a:rPr lang="en-US"/>
               <a:t>Third level</a:t>
             </a:r>
           </a:p>
           <a:p>
             <a:pPr lvl="3"/>
             <a:r>
-              <a:rPr lang="en-US" smtClean="0"/>
+              <a:rPr lang="en-US"/>
               <a:t>Fourth level</a:t>
             </a:r>
           </a:p>
           <a:p>
             <a:pPr lvl="4"/>
             <a:r>
-              <a:rPr lang="en-US" smtClean="0"/>
+              <a:rPr lang="en-US"/>
               <a:t>Fifth level</a:t>
             </a:r>
-            <a:endParaRPr lang="en-US"/>
           </a:p>
         </p:txBody>
       </p:sp>
@@ -2240,7 +2238,7 @@
           <a:p>
             <a:pPr lvl="0"/>
             <a:r>
-              <a:rPr lang="en-US" smtClean="0"/>
+              <a:rPr lang="en-US"/>
               <a:t>Click to edit Master text styles</a:t>
             </a:r>
           </a:p>
@@ -2263,7 +2261,7 @@
           <a:p>
             <a:fld id="{5BCAD085-E8A6-8845-BD4E-CB4CCA059FC4}" type="datetimeFigureOut">
               <a:rPr lang="en-US" smtClean="0"/>
-              <a:t>1/27/13</a:t>
+              <a:t>7/17/26</a:t>
             </a:fld>
             <a:endParaRPr lang="en-US"/>
           </a:p>
@@ -2366,10 +2364,9 @@
           </a:lstStyle>
           <a:p>
             <a:r>
-              <a:rPr lang="en-US" smtClean="0"/>
+              <a:rPr lang="en-US"/>
               <a:t>Click to edit Master title style</a:t>
             </a:r>
-            <a:endParaRPr lang="en-US"/>
           </a:p>
         </p:txBody>
       </p:sp>
@@ -2493,7 +2490,7 @@
           <a:p>
             <a:pPr lvl="0"/>
             <a:r>
-              <a:rPr lang="en-US" smtClean="0"/>
+              <a:rPr lang="en-US"/>
               <a:t>Click to edit Master text styles</a:t>
             </a:r>
           </a:p>
@@ -2516,7 +2513,7 @@
           <a:p>
             <a:fld id="{5BCAD085-E8A6-8845-BD4E-CB4CCA059FC4}" type="datetimeFigureOut">
               <a:rPr lang="en-US" smtClean="0"/>
-              <a:t>1/27/13</a:t>
+              <a:t>7/17/26</a:t>
             </a:fld>
             <a:endParaRPr lang="en-US"/>
           </a:p>
@@ -2625,10 +2622,9 @@
           <a:lstStyle/>
           <a:p>
             <a:r>
-              <a:rPr lang="en-US" smtClean="0"/>
+              <a:rPr lang="en-US"/>
               <a:t>Click to edit Master title style</a:t>
             </a:r>
-            <a:endParaRPr lang="en-US"/>
           </a:p>
         </p:txBody>
       </p:sp>
@@ -2659,38 +2655,37 @@
           <a:p>
             <a:pPr lvl="0"/>
             <a:r>
-              <a:rPr lang="en-US" smtClean="0"/>
+              <a:rPr lang="en-US"/>
               <a:t>Click to edit Master text styles</a:t>
             </a:r>
           </a:p>
           <a:p>
             <a:pPr lvl="1"/>
             <a:r>
-              <a:rPr lang="en-US" smtClean="0"/>
+              <a:rPr lang="en-US"/>
               <a:t>Second level</a:t>
             </a:r>
           </a:p>
           <a:p>
             <a:pPr lvl="2"/>
             <a:r>
-              <a:rPr lang="en-US" smtClean="0"/>
+              <a:rPr lang="en-US"/>
               <a:t>Third level</a:t>
             </a:r>
           </a:p>
           <a:p>
             <a:pPr lvl="3"/>
             <a:r>
-              <a:rPr lang="en-US" smtClean="0"/>
+              <a:rPr lang="en-US"/>
               <a:t>Fourth level</a:t>
             </a:r>
           </a:p>
           <a:p>
             <a:pPr lvl="4"/>
             <a:r>
-              <a:rPr lang="en-US" smtClean="0"/>
+              <a:rPr lang="en-US"/>
               <a:t>Fifth level</a:t>
             </a:r>
-            <a:endParaRPr lang="en-US"/>
           </a:p>
         </p:txBody>
       </p:sp>
@@ -2729,7 +2724,7 @@
           <a:p>
             <a:fld id="{5BCAD085-E8A6-8845-BD4E-CB4CCA059FC4}" type="datetimeFigureOut">
               <a:rPr lang="en-US" smtClean="0"/>
-              <a:t>1/27/13</a:t>
+              <a:t>7/17/26</a:t>
             </a:fld>
             <a:endParaRPr lang="en-US"/>
           </a:p>
@@ -3088,7 +3083,7 @@
 </file>
 
 <file path=ppt/slides/slide1.xml><?xml version="1.0" encoding="utf-8"?>
-<p:sld xmlns:a="http://schemas.openxmlformats.org/drawingml/2006/main" xmlns:p="http://schemas.openxmlformats.org/presentationml/2006/main" xmlns:r="http://schemas.openxmlformats.org/officeDocument/2006/relationships">
+<p:sld xmlns:a="http://schemas.openxmlformats.org/drawingml/2006/main" xmlns:r="http://schemas.openxmlformats.org/officeDocument/2006/relationships" xmlns:p="http://schemas.openxmlformats.org/presentationml/2006/main">
   <p:cSld>
     <p:spTree>
       <p:nvGrpSpPr>
@@ -3096,7 +3091,14 @@
         <p:cNvGrpSpPr/>
         <p:nvPr/>
       </p:nvGrpSpPr>
-      <p:grpSpPr/>
+      <p:grpSpPr>
+        <a:xfrm>
+          <a:off x="0" y="0"/>
+          <a:ext cx="0" cy="0"/>
+          <a:chOff x="0" y="0"/>
+          <a:chExt cx="0" cy="0"/>
+        </a:xfrm>
+      </p:grpSpPr>
       <p:sp>
         <p:nvSpPr>
           <p:cNvPr id="2" name="Rectangle 1"/>
@@ -3138,6 +3140,7 @@
           <a:lstStyle/>
           <a:p>
             <a:pPr algn="ctr"/>
+            <a:endParaRPr/>
           </a:p>
         </p:txBody>
       </p:sp>
@@ -3158,7 +3161,7 @@
           <a:noFill/>
         </p:spPr>
         <p:txBody>
-          <a:bodyPr wrap="square" lIns="0" rIns="0" tIns="0" bIns="0">
+          <a:bodyPr wrap="square" lIns="0" tIns="0" rIns="0" bIns="0">
             <a:spAutoFit/>
           </a:bodyPr>
           <a:lstStyle/>
@@ -3201,7 +3204,7 @@
           <a:noFill/>
         </p:spPr>
         <p:txBody>
-          <a:bodyPr wrap="square" lIns="0" rIns="0" tIns="0" bIns="0">
+          <a:bodyPr wrap="square" lIns="0" tIns="0" rIns="0" bIns="0">
             <a:spAutoFit/>
           </a:bodyPr>
           <a:lstStyle/>
@@ -3249,7 +3252,7 @@
           <a:noFill/>
         </p:spPr>
         <p:txBody>
-          <a:bodyPr wrap="square" lIns="0" rIns="0" tIns="0" bIns="0">
+          <a:bodyPr wrap="square" lIns="0" tIns="0" rIns="0" bIns="0">
             <a:spAutoFit/>
           </a:bodyPr>
           <a:lstStyle/>
@@ -3288,7 +3291,7 @@
           <a:noFill/>
         </p:spPr>
         <p:txBody>
-          <a:bodyPr wrap="square" lIns="0" rIns="0" tIns="0" bIns="0">
+          <a:bodyPr wrap="square" lIns="0" tIns="0" rIns="0" bIns="0">
             <a:spAutoFit/>
           </a:bodyPr>
           <a:lstStyle/>
@@ -3335,7 +3338,7 @@
 </file>
 
 <file path=ppt/slides/slide10.xml><?xml version="1.0" encoding="utf-8"?>
-<p:sld xmlns:a="http://schemas.openxmlformats.org/drawingml/2006/main" xmlns:p="http://schemas.openxmlformats.org/presentationml/2006/main" xmlns:r="http://schemas.openxmlformats.org/officeDocument/2006/relationships">
+<p:sld xmlns:a="http://schemas.openxmlformats.org/drawingml/2006/main" xmlns:r="http://schemas.openxmlformats.org/officeDocument/2006/relationships" xmlns:p="http://schemas.openxmlformats.org/presentationml/2006/main">
   <p:cSld>
     <p:spTree>
       <p:nvGrpSpPr>
@@ -3343,7 +3346,14 @@
         <p:cNvGrpSpPr/>
         <p:nvPr/>
       </p:nvGrpSpPr>
-      <p:grpSpPr/>
+      <p:grpSpPr>
+        <a:xfrm>
+          <a:off x="0" y="0"/>
+          <a:ext cx="0" cy="0"/>
+          <a:chOff x="0" y="0"/>
+          <a:chExt cx="0" cy="0"/>
+        </a:xfrm>
+      </p:grpSpPr>
       <p:sp>
         <p:nvSpPr>
           <p:cNvPr id="2" name="TextBox 1"/>
@@ -3361,7 +3371,7 @@
           <a:noFill/>
         </p:spPr>
         <p:txBody>
-          <a:bodyPr wrap="square" lIns="0" rIns="0" tIns="0" bIns="0">
+          <a:bodyPr wrap="square" lIns="0" tIns="0" rIns="0" bIns="0">
             <a:spAutoFit/>
           </a:bodyPr>
           <a:lstStyle/>
@@ -3400,7 +3410,7 @@
           <a:noFill/>
         </p:spPr>
         <p:txBody>
-          <a:bodyPr wrap="square" lIns="0" rIns="0" tIns="0" bIns="0">
+          <a:bodyPr wrap="square" lIns="0" tIns="0" rIns="0" bIns="0">
             <a:spAutoFit/>
           </a:bodyPr>
           <a:lstStyle/>
@@ -3537,7 +3547,7 @@
           <a:noFill/>
         </p:spPr>
         <p:txBody>
-          <a:bodyPr wrap="square" lIns="0" rIns="0" tIns="0" bIns="0">
+          <a:bodyPr wrap="square" lIns="0" tIns="0" rIns="0" bIns="0">
             <a:spAutoFit/>
           </a:bodyPr>
           <a:lstStyle/>
@@ -3576,7 +3586,7 @@
           <a:noFill/>
         </p:spPr>
         <p:txBody>
-          <a:bodyPr wrap="square" lIns="0" rIns="0" tIns="0" bIns="0">
+          <a:bodyPr wrap="square" lIns="0" tIns="0" rIns="0" bIns="0">
             <a:spAutoFit/>
           </a:bodyPr>
           <a:lstStyle/>
@@ -3694,7 +3704,7 @@
           <a:noFill/>
         </p:spPr>
         <p:txBody>
-          <a:bodyPr wrap="square" lIns="0" rIns="0" tIns="0" bIns="0">
+          <a:bodyPr wrap="square" lIns="0" tIns="0" rIns="0" bIns="0">
             <a:spAutoFit/>
           </a:bodyPr>
           <a:lstStyle/>
@@ -3728,7 +3738,7 @@
 </file>
 
 <file path=ppt/slides/slide2.xml><?xml version="1.0" encoding="utf-8"?>
-<p:sld xmlns:a="http://schemas.openxmlformats.org/drawingml/2006/main" xmlns:p="http://schemas.openxmlformats.org/presentationml/2006/main" xmlns:r="http://schemas.openxmlformats.org/officeDocument/2006/relationships">
+<p:sld xmlns:a="http://schemas.openxmlformats.org/drawingml/2006/main" xmlns:r="http://schemas.openxmlformats.org/officeDocument/2006/relationships" xmlns:p="http://schemas.openxmlformats.org/presentationml/2006/main">
   <p:cSld>
     <p:spTree>
       <p:nvGrpSpPr>
@@ -3736,7 +3746,14 @@
         <p:cNvGrpSpPr/>
         <p:nvPr/>
       </p:nvGrpSpPr>
-      <p:grpSpPr/>
+      <p:grpSpPr>
+        <a:xfrm>
+          <a:off x="0" y="0"/>
+          <a:ext cx="0" cy="0"/>
+          <a:chOff x="0" y="0"/>
+          <a:chExt cx="0" cy="0"/>
+        </a:xfrm>
+      </p:grpSpPr>
       <p:sp>
         <p:nvSpPr>
           <p:cNvPr id="2" name="TextBox 1"/>
@@ -3754,7 +3771,7 @@
           <a:noFill/>
         </p:spPr>
         <p:txBody>
-          <a:bodyPr wrap="square" lIns="0" rIns="0" tIns="0" bIns="0">
+          <a:bodyPr wrap="square" lIns="0" tIns="0" rIns="0" bIns="0">
             <a:spAutoFit/>
           </a:bodyPr>
           <a:lstStyle/>
@@ -3815,7 +3832,9 @@
         <p:txBody>
           <a:bodyPr rtlCol="0" anchor="ctr"/>
           <a:lstStyle/>
-          <a:p/>
+          <a:p>
+            <a:endParaRPr/>
+          </a:p>
         </p:txBody>
       </p:sp>
       <p:sp>
@@ -3857,7 +3876,9 @@
         <p:txBody>
           <a:bodyPr rtlCol="0" anchor="ctr"/>
           <a:lstStyle/>
-          <a:p/>
+          <a:p>
+            <a:endParaRPr/>
+          </a:p>
         </p:txBody>
       </p:sp>
       <p:sp>
@@ -3899,7 +3920,9 @@
         <p:txBody>
           <a:bodyPr rtlCol="0" anchor="ctr"/>
           <a:lstStyle/>
-          <a:p/>
+          <a:p>
+            <a:endParaRPr/>
+          </a:p>
         </p:txBody>
       </p:sp>
       <p:sp>
@@ -3941,7 +3964,9 @@
         <p:txBody>
           <a:bodyPr rtlCol="0" anchor="ctr"/>
           <a:lstStyle/>
-          <a:p/>
+          <a:p>
+            <a:endParaRPr/>
+          </a:p>
         </p:txBody>
       </p:sp>
       <p:sp>
@@ -3983,7 +4008,9 @@
         <p:txBody>
           <a:bodyPr rtlCol="0" anchor="ctr"/>
           <a:lstStyle/>
-          <a:p/>
+          <a:p>
+            <a:endParaRPr/>
+          </a:p>
         </p:txBody>
       </p:sp>
       <p:sp>
@@ -4025,7 +4052,9 @@
         <p:txBody>
           <a:bodyPr rtlCol="0" anchor="ctr"/>
           <a:lstStyle/>
-          <a:p/>
+          <a:p>
+            <a:endParaRPr/>
+          </a:p>
         </p:txBody>
       </p:sp>
       <p:sp>
@@ -4067,7 +4096,9 @@
         <p:txBody>
           <a:bodyPr rtlCol="0" anchor="ctr"/>
           <a:lstStyle/>
-          <a:p/>
+          <a:p>
+            <a:endParaRPr/>
+          </a:p>
         </p:txBody>
       </p:sp>
       <p:sp>
@@ -4109,7 +4140,9 @@
         <p:txBody>
           <a:bodyPr rtlCol="0" anchor="ctr"/>
           <a:lstStyle/>
-          <a:p/>
+          <a:p>
+            <a:endParaRPr/>
+          </a:p>
         </p:txBody>
       </p:sp>
       <p:sp>
@@ -4151,7 +4184,9 @@
         <p:txBody>
           <a:bodyPr rtlCol="0" anchor="ctr"/>
           <a:lstStyle/>
-          <a:p/>
+          <a:p>
+            <a:endParaRPr/>
+          </a:p>
         </p:txBody>
       </p:sp>
       <p:sp>
@@ -4193,7 +4228,9 @@
         <p:txBody>
           <a:bodyPr rtlCol="0" anchor="ctr"/>
           <a:lstStyle/>
-          <a:p/>
+          <a:p>
+            <a:endParaRPr/>
+          </a:p>
         </p:txBody>
       </p:sp>
       <p:sp>
@@ -4235,7 +4272,9 @@
         <p:txBody>
           <a:bodyPr rtlCol="0" anchor="ctr"/>
           <a:lstStyle/>
-          <a:p/>
+          <a:p>
+            <a:endParaRPr/>
+          </a:p>
         </p:txBody>
       </p:sp>
       <p:sp>
@@ -4277,7 +4316,9 @@
         <p:txBody>
           <a:bodyPr rtlCol="0" anchor="ctr"/>
           <a:lstStyle/>
-          <a:p/>
+          <a:p>
+            <a:endParaRPr/>
+          </a:p>
         </p:txBody>
       </p:sp>
       <p:sp>
@@ -4319,7 +4360,9 @@
         <p:txBody>
           <a:bodyPr rtlCol="0" anchor="ctr"/>
           <a:lstStyle/>
-          <a:p/>
+          <a:p>
+            <a:endParaRPr/>
+          </a:p>
         </p:txBody>
       </p:sp>
       <p:sp>
@@ -4361,7 +4404,9 @@
         <p:txBody>
           <a:bodyPr rtlCol="0" anchor="ctr"/>
           <a:lstStyle/>
-          <a:p/>
+          <a:p>
+            <a:endParaRPr/>
+          </a:p>
         </p:txBody>
       </p:sp>
       <p:sp>
@@ -4403,7 +4448,9 @@
         <p:txBody>
           <a:bodyPr rtlCol="0" anchor="ctr"/>
           <a:lstStyle/>
-          <a:p/>
+          <a:p>
+            <a:endParaRPr/>
+          </a:p>
         </p:txBody>
       </p:sp>
       <p:sp>
@@ -4445,7 +4492,9 @@
         <p:txBody>
           <a:bodyPr rtlCol="0" anchor="ctr"/>
           <a:lstStyle/>
-          <a:p/>
+          <a:p>
+            <a:endParaRPr/>
+          </a:p>
         </p:txBody>
       </p:sp>
       <p:sp>
@@ -4487,7 +4536,9 @@
         <p:txBody>
           <a:bodyPr rtlCol="0" anchor="ctr"/>
           <a:lstStyle/>
-          <a:p/>
+          <a:p>
+            <a:endParaRPr/>
+          </a:p>
         </p:txBody>
       </p:sp>
       <p:sp>
@@ -4529,7 +4580,9 @@
         <p:txBody>
           <a:bodyPr rtlCol="0" anchor="ctr"/>
           <a:lstStyle/>
-          <a:p/>
+          <a:p>
+            <a:endParaRPr/>
+          </a:p>
         </p:txBody>
       </p:sp>
       <p:sp>
@@ -4571,7 +4624,9 @@
         <p:txBody>
           <a:bodyPr rtlCol="0" anchor="ctr"/>
           <a:lstStyle/>
-          <a:p/>
+          <a:p>
+            <a:endParaRPr/>
+          </a:p>
         </p:txBody>
       </p:sp>
       <p:sp>
@@ -4613,7 +4668,9 @@
         <p:txBody>
           <a:bodyPr rtlCol="0" anchor="ctr"/>
           <a:lstStyle/>
-          <a:p/>
+          <a:p>
+            <a:endParaRPr/>
+          </a:p>
         </p:txBody>
       </p:sp>
       <p:sp>
@@ -4655,7 +4712,9 @@
         <p:txBody>
           <a:bodyPr rtlCol="0" anchor="ctr"/>
           <a:lstStyle/>
-          <a:p/>
+          <a:p>
+            <a:endParaRPr/>
+          </a:p>
         </p:txBody>
       </p:sp>
       <p:sp>
@@ -4697,7 +4756,9 @@
         <p:txBody>
           <a:bodyPr rtlCol="0" anchor="ctr"/>
           <a:lstStyle/>
-          <a:p/>
+          <a:p>
+            <a:endParaRPr/>
+          </a:p>
         </p:txBody>
       </p:sp>
       <p:sp>
@@ -4739,7 +4800,9 @@
         <p:txBody>
           <a:bodyPr rtlCol="0" anchor="ctr"/>
           <a:lstStyle/>
-          <a:p/>
+          <a:p>
+            <a:endParaRPr/>
+          </a:p>
         </p:txBody>
       </p:sp>
       <p:sp>
@@ -4781,7 +4844,9 @@
         <p:txBody>
           <a:bodyPr rtlCol="0" anchor="ctr"/>
           <a:lstStyle/>
-          <a:p/>
+          <a:p>
+            <a:endParaRPr/>
+          </a:p>
         </p:txBody>
       </p:sp>
       <p:sp>
@@ -4823,7 +4888,9 @@
         <p:txBody>
           <a:bodyPr rtlCol="0" anchor="ctr"/>
           <a:lstStyle/>
-          <a:p/>
+          <a:p>
+            <a:endParaRPr/>
+          </a:p>
         </p:txBody>
       </p:sp>
       <p:sp>
@@ -4865,7 +4932,9 @@
         <p:txBody>
           <a:bodyPr rtlCol="0" anchor="ctr"/>
           <a:lstStyle/>
-          <a:p/>
+          <a:p>
+            <a:endParaRPr/>
+          </a:p>
         </p:txBody>
       </p:sp>
       <p:sp>
@@ -4907,7 +4976,9 @@
         <p:txBody>
           <a:bodyPr rtlCol="0" anchor="ctr"/>
           <a:lstStyle/>
-          <a:p/>
+          <a:p>
+            <a:endParaRPr/>
+          </a:p>
         </p:txBody>
       </p:sp>
       <p:sp>
@@ -4949,7 +5020,9 @@
         <p:txBody>
           <a:bodyPr rtlCol="0" anchor="ctr"/>
           <a:lstStyle/>
-          <a:p/>
+          <a:p>
+            <a:endParaRPr/>
+          </a:p>
         </p:txBody>
       </p:sp>
       <p:sp>
@@ -4991,7 +5064,9 @@
         <p:txBody>
           <a:bodyPr rtlCol="0" anchor="ctr"/>
           <a:lstStyle/>
-          <a:p/>
+          <a:p>
+            <a:endParaRPr/>
+          </a:p>
         </p:txBody>
       </p:sp>
       <p:sp>
@@ -5033,7 +5108,9 @@
         <p:txBody>
           <a:bodyPr rtlCol="0" anchor="ctr"/>
           <a:lstStyle/>
-          <a:p/>
+          <a:p>
+            <a:endParaRPr/>
+          </a:p>
         </p:txBody>
       </p:sp>
       <p:sp>
@@ -5075,7 +5152,9 @@
         <p:txBody>
           <a:bodyPr rtlCol="0" anchor="ctr"/>
           <a:lstStyle/>
-          <a:p/>
+          <a:p>
+            <a:endParaRPr/>
+          </a:p>
         </p:txBody>
       </p:sp>
       <p:sp>
@@ -5117,7 +5196,9 @@
         <p:txBody>
           <a:bodyPr rtlCol="0" anchor="ctr"/>
           <a:lstStyle/>
-          <a:p/>
+          <a:p>
+            <a:endParaRPr/>
+          </a:p>
         </p:txBody>
       </p:sp>
       <p:sp>
@@ -5159,7 +5240,9 @@
         <p:txBody>
           <a:bodyPr rtlCol="0" anchor="ctr"/>
           <a:lstStyle/>
-          <a:p/>
+          <a:p>
+            <a:endParaRPr/>
+          </a:p>
         </p:txBody>
       </p:sp>
       <p:sp>
@@ -5201,7 +5284,9 @@
         <p:txBody>
           <a:bodyPr rtlCol="0" anchor="ctr"/>
           <a:lstStyle/>
-          <a:p/>
+          <a:p>
+            <a:endParaRPr/>
+          </a:p>
         </p:txBody>
       </p:sp>
       <p:sp>
@@ -5243,7 +5328,9 @@
         <p:txBody>
           <a:bodyPr rtlCol="0" anchor="ctr"/>
           <a:lstStyle/>
-          <a:p/>
+          <a:p>
+            <a:endParaRPr/>
+          </a:p>
         </p:txBody>
       </p:sp>
       <p:sp>
@@ -5285,7 +5372,9 @@
         <p:txBody>
           <a:bodyPr rtlCol="0" anchor="ctr"/>
           <a:lstStyle/>
-          <a:p/>
+          <a:p>
+            <a:endParaRPr/>
+          </a:p>
         </p:txBody>
       </p:sp>
       <p:sp>
@@ -5327,7 +5416,9 @@
         <p:txBody>
           <a:bodyPr rtlCol="0" anchor="ctr"/>
           <a:lstStyle/>
-          <a:p/>
+          <a:p>
+            <a:endParaRPr/>
+          </a:p>
         </p:txBody>
       </p:sp>
       <p:sp>
@@ -5369,7 +5460,9 @@
         <p:txBody>
           <a:bodyPr rtlCol="0" anchor="ctr"/>
           <a:lstStyle/>
-          <a:p/>
+          <a:p>
+            <a:endParaRPr/>
+          </a:p>
         </p:txBody>
       </p:sp>
       <p:sp>
@@ -5411,7 +5504,9 @@
         <p:txBody>
           <a:bodyPr rtlCol="0" anchor="ctr"/>
           <a:lstStyle/>
-          <a:p/>
+          <a:p>
+            <a:endParaRPr/>
+          </a:p>
         </p:txBody>
       </p:sp>
       <p:sp>
@@ -5453,7 +5548,9 @@
         <p:txBody>
           <a:bodyPr rtlCol="0" anchor="ctr"/>
           <a:lstStyle/>
-          <a:p/>
+          <a:p>
+            <a:endParaRPr/>
+          </a:p>
         </p:txBody>
       </p:sp>
       <p:sp>
@@ -5495,7 +5592,9 @@
         <p:txBody>
           <a:bodyPr rtlCol="0" anchor="ctr"/>
           <a:lstStyle/>
-          <a:p/>
+          <a:p>
+            <a:endParaRPr/>
+          </a:p>
         </p:txBody>
       </p:sp>
       <p:sp>
@@ -5537,7 +5636,9 @@
         <p:txBody>
           <a:bodyPr rtlCol="0" anchor="ctr"/>
           <a:lstStyle/>
-          <a:p/>
+          <a:p>
+            <a:endParaRPr/>
+          </a:p>
         </p:txBody>
       </p:sp>
       <p:sp>
@@ -5579,7 +5680,9 @@
         <p:txBody>
           <a:bodyPr rtlCol="0" anchor="ctr"/>
           <a:lstStyle/>
-          <a:p/>
+          <a:p>
+            <a:endParaRPr/>
+          </a:p>
         </p:txBody>
       </p:sp>
       <p:sp>
@@ -5621,7 +5724,9 @@
         <p:txBody>
           <a:bodyPr rtlCol="0" anchor="ctr"/>
           <a:lstStyle/>
-          <a:p/>
+          <a:p>
+            <a:endParaRPr/>
+          </a:p>
         </p:txBody>
       </p:sp>
       <p:sp>
@@ -5663,7 +5768,9 @@
         <p:txBody>
           <a:bodyPr rtlCol="0" anchor="ctr"/>
           <a:lstStyle/>
-          <a:p/>
+          <a:p>
+            <a:endParaRPr/>
+          </a:p>
         </p:txBody>
       </p:sp>
       <p:sp>
@@ -5705,7 +5812,9 @@
         <p:txBody>
           <a:bodyPr rtlCol="0" anchor="ctr"/>
           <a:lstStyle/>
-          <a:p/>
+          <a:p>
+            <a:endParaRPr/>
+          </a:p>
         </p:txBody>
       </p:sp>
       <p:sp>
@@ -5747,7 +5856,9 @@
         <p:txBody>
           <a:bodyPr rtlCol="0" anchor="ctr"/>
           <a:lstStyle/>
-          <a:p/>
+          <a:p>
+            <a:endParaRPr/>
+          </a:p>
         </p:txBody>
       </p:sp>
       <p:sp>
@@ -5789,7 +5900,9 @@
         <p:txBody>
           <a:bodyPr rtlCol="0" anchor="ctr"/>
           <a:lstStyle/>
-          <a:p/>
+          <a:p>
+            <a:endParaRPr/>
+          </a:p>
         </p:txBody>
       </p:sp>
       <p:sp>
@@ -5831,7 +5944,9 @@
         <p:txBody>
           <a:bodyPr rtlCol="0" anchor="ctr"/>
           <a:lstStyle/>
-          <a:p/>
+          <a:p>
+            <a:endParaRPr/>
+          </a:p>
         </p:txBody>
       </p:sp>
       <p:sp>
@@ -5873,7 +5988,9 @@
         <p:txBody>
           <a:bodyPr rtlCol="0" anchor="ctr"/>
           <a:lstStyle/>
-          <a:p/>
+          <a:p>
+            <a:endParaRPr/>
+          </a:p>
         </p:txBody>
       </p:sp>
       <p:sp>
@@ -5915,7 +6032,9 @@
         <p:txBody>
           <a:bodyPr rtlCol="0" anchor="ctr"/>
           <a:lstStyle/>
-          <a:p/>
+          <a:p>
+            <a:endParaRPr/>
+          </a:p>
         </p:txBody>
       </p:sp>
       <p:sp>
@@ -5957,7 +6076,9 @@
         <p:txBody>
           <a:bodyPr rtlCol="0" anchor="ctr"/>
           <a:lstStyle/>
-          <a:p/>
+          <a:p>
+            <a:endParaRPr/>
+          </a:p>
         </p:txBody>
       </p:sp>
       <p:sp>
@@ -5999,7 +6120,9 @@
         <p:txBody>
           <a:bodyPr rtlCol="0" anchor="ctr"/>
           <a:lstStyle/>
-          <a:p/>
+          <a:p>
+            <a:endParaRPr/>
+          </a:p>
         </p:txBody>
       </p:sp>
       <p:sp>
@@ -6041,7 +6164,9 @@
         <p:txBody>
           <a:bodyPr rtlCol="0" anchor="ctr"/>
           <a:lstStyle/>
-          <a:p/>
+          <a:p>
+            <a:endParaRPr/>
+          </a:p>
         </p:txBody>
       </p:sp>
       <p:sp>
@@ -6083,7 +6208,9 @@
         <p:txBody>
           <a:bodyPr rtlCol="0" anchor="ctr"/>
           <a:lstStyle/>
-          <a:p/>
+          <a:p>
+            <a:endParaRPr/>
+          </a:p>
         </p:txBody>
       </p:sp>
       <p:sp>
@@ -6125,7 +6252,9 @@
         <p:txBody>
           <a:bodyPr rtlCol="0" anchor="ctr"/>
           <a:lstStyle/>
-          <a:p/>
+          <a:p>
+            <a:endParaRPr/>
+          </a:p>
         </p:txBody>
       </p:sp>
       <p:sp>
@@ -6167,7 +6296,9 @@
         <p:txBody>
           <a:bodyPr rtlCol="0" anchor="ctr"/>
           <a:lstStyle/>
-          <a:p/>
+          <a:p>
+            <a:endParaRPr/>
+          </a:p>
         </p:txBody>
       </p:sp>
       <p:sp>
@@ -6209,7 +6340,9 @@
         <p:txBody>
           <a:bodyPr rtlCol="0" anchor="ctr"/>
           <a:lstStyle/>
-          <a:p/>
+          <a:p>
+            <a:endParaRPr/>
+          </a:p>
         </p:txBody>
       </p:sp>
       <p:sp>
@@ -6251,7 +6384,9 @@
         <p:txBody>
           <a:bodyPr rtlCol="0" anchor="ctr"/>
           <a:lstStyle/>
-          <a:p/>
+          <a:p>
+            <a:endParaRPr/>
+          </a:p>
         </p:txBody>
       </p:sp>
       <p:sp>
@@ -6293,7 +6428,9 @@
         <p:txBody>
           <a:bodyPr rtlCol="0" anchor="ctr"/>
           <a:lstStyle/>
-          <a:p/>
+          <a:p>
+            <a:endParaRPr/>
+          </a:p>
         </p:txBody>
       </p:sp>
       <p:sp>
@@ -6335,7 +6472,9 @@
         <p:txBody>
           <a:bodyPr rtlCol="0" anchor="ctr"/>
           <a:lstStyle/>
-          <a:p/>
+          <a:p>
+            <a:endParaRPr/>
+          </a:p>
         </p:txBody>
       </p:sp>
       <p:sp>
@@ -6377,7 +6516,9 @@
         <p:txBody>
           <a:bodyPr rtlCol="0" anchor="ctr"/>
           <a:lstStyle/>
-          <a:p/>
+          <a:p>
+            <a:endParaRPr/>
+          </a:p>
         </p:txBody>
       </p:sp>
       <p:sp>
@@ -6419,7 +6560,9 @@
         <p:txBody>
           <a:bodyPr rtlCol="0" anchor="ctr"/>
           <a:lstStyle/>
-          <a:p/>
+          <a:p>
+            <a:endParaRPr/>
+          </a:p>
         </p:txBody>
       </p:sp>
       <p:sp>
@@ -6461,7 +6604,9 @@
         <p:txBody>
           <a:bodyPr rtlCol="0" anchor="ctr"/>
           <a:lstStyle/>
-          <a:p/>
+          <a:p>
+            <a:endParaRPr/>
+          </a:p>
         </p:txBody>
       </p:sp>
       <p:sp>
@@ -6503,7 +6648,9 @@
         <p:txBody>
           <a:bodyPr rtlCol="0" anchor="ctr"/>
           <a:lstStyle/>
-          <a:p/>
+          <a:p>
+            <a:endParaRPr/>
+          </a:p>
         </p:txBody>
       </p:sp>
       <p:sp>
@@ -6545,7 +6692,9 @@
         <p:txBody>
           <a:bodyPr rtlCol="0" anchor="ctr"/>
           <a:lstStyle/>
-          <a:p/>
+          <a:p>
+            <a:endParaRPr/>
+          </a:p>
         </p:txBody>
       </p:sp>
       <p:sp>
@@ -6587,7 +6736,9 @@
         <p:txBody>
           <a:bodyPr rtlCol="0" anchor="ctr"/>
           <a:lstStyle/>
-          <a:p/>
+          <a:p>
+            <a:endParaRPr/>
+          </a:p>
         </p:txBody>
       </p:sp>
       <p:sp>
@@ -6629,7 +6780,9 @@
         <p:txBody>
           <a:bodyPr rtlCol="0" anchor="ctr"/>
           <a:lstStyle/>
-          <a:p/>
+          <a:p>
+            <a:endParaRPr/>
+          </a:p>
         </p:txBody>
       </p:sp>
       <p:sp>
@@ -6671,7 +6824,9 @@
         <p:txBody>
           <a:bodyPr rtlCol="0" anchor="ctr"/>
           <a:lstStyle/>
-          <a:p/>
+          <a:p>
+            <a:endParaRPr/>
+          </a:p>
         </p:txBody>
       </p:sp>
       <p:sp>
@@ -6713,7 +6868,9 @@
         <p:txBody>
           <a:bodyPr rtlCol="0" anchor="ctr"/>
           <a:lstStyle/>
-          <a:p/>
+          <a:p>
+            <a:endParaRPr/>
+          </a:p>
         </p:txBody>
       </p:sp>
       <p:sp>
@@ -6755,7 +6912,9 @@
         <p:txBody>
           <a:bodyPr rtlCol="0" anchor="ctr"/>
           <a:lstStyle/>
-          <a:p/>
+          <a:p>
+            <a:endParaRPr/>
+          </a:p>
         </p:txBody>
       </p:sp>
       <p:sp>
@@ -6797,7 +6956,9 @@
         <p:txBody>
           <a:bodyPr rtlCol="0" anchor="ctr"/>
           <a:lstStyle/>
-          <a:p/>
+          <a:p>
+            <a:endParaRPr/>
+          </a:p>
         </p:txBody>
       </p:sp>
       <p:sp>
@@ -6839,7 +7000,9 @@
         <p:txBody>
           <a:bodyPr rtlCol="0" anchor="ctr"/>
           <a:lstStyle/>
-          <a:p/>
+          <a:p>
+            <a:endParaRPr/>
+          </a:p>
         </p:txBody>
       </p:sp>
       <p:sp>
@@ -6881,7 +7044,9 @@
         <p:txBody>
           <a:bodyPr rtlCol="0" anchor="ctr"/>
           <a:lstStyle/>
-          <a:p/>
+          <a:p>
+            <a:endParaRPr/>
+          </a:p>
         </p:txBody>
       </p:sp>
       <p:sp>
@@ -6923,7 +7088,9 @@
         <p:txBody>
           <a:bodyPr rtlCol="0" anchor="ctr"/>
           <a:lstStyle/>
-          <a:p/>
+          <a:p>
+            <a:endParaRPr/>
+          </a:p>
         </p:txBody>
       </p:sp>
       <p:sp>
@@ -6965,7 +7132,9 @@
         <p:txBody>
           <a:bodyPr rtlCol="0" anchor="ctr"/>
           <a:lstStyle/>
-          <a:p/>
+          <a:p>
+            <a:endParaRPr/>
+          </a:p>
         </p:txBody>
       </p:sp>
       <p:sp>
@@ -7007,7 +7176,9 @@
         <p:txBody>
           <a:bodyPr rtlCol="0" anchor="ctr"/>
           <a:lstStyle/>
-          <a:p/>
+          <a:p>
+            <a:endParaRPr/>
+          </a:p>
         </p:txBody>
       </p:sp>
       <p:sp>
@@ -7049,7 +7220,9 @@
         <p:txBody>
           <a:bodyPr rtlCol="0" anchor="ctr"/>
           <a:lstStyle/>
-          <a:p/>
+          <a:p>
+            <a:endParaRPr/>
+          </a:p>
         </p:txBody>
       </p:sp>
       <p:sp>
@@ -7091,7 +7264,9 @@
         <p:txBody>
           <a:bodyPr rtlCol="0" anchor="ctr"/>
           <a:lstStyle/>
-          <a:p/>
+          <a:p>
+            <a:endParaRPr/>
+          </a:p>
         </p:txBody>
       </p:sp>
       <p:sp>
@@ -7133,7 +7308,9 @@
         <p:txBody>
           <a:bodyPr rtlCol="0" anchor="ctr"/>
           <a:lstStyle/>
-          <a:p/>
+          <a:p>
+            <a:endParaRPr/>
+          </a:p>
         </p:txBody>
       </p:sp>
       <p:sp>
@@ -7175,7 +7352,9 @@
         <p:txBody>
           <a:bodyPr rtlCol="0" anchor="ctr"/>
           <a:lstStyle/>
-          <a:p/>
+          <a:p>
+            <a:endParaRPr/>
+          </a:p>
         </p:txBody>
       </p:sp>
       <p:sp>
@@ -7217,7 +7396,9 @@
         <p:txBody>
           <a:bodyPr rtlCol="0" anchor="ctr"/>
           <a:lstStyle/>
-          <a:p/>
+          <a:p>
+            <a:endParaRPr/>
+          </a:p>
         </p:txBody>
       </p:sp>
       <p:sp>
@@ -7259,7 +7440,9 @@
         <p:txBody>
           <a:bodyPr rtlCol="0" anchor="ctr"/>
           <a:lstStyle/>
-          <a:p/>
+          <a:p>
+            <a:endParaRPr/>
+          </a:p>
         </p:txBody>
       </p:sp>
       <p:sp>
@@ -7301,7 +7484,9 @@
         <p:txBody>
           <a:bodyPr rtlCol="0" anchor="ctr"/>
           <a:lstStyle/>
-          <a:p/>
+          <a:p>
+            <a:endParaRPr/>
+          </a:p>
         </p:txBody>
       </p:sp>
       <p:sp>
@@ -7343,7 +7528,9 @@
         <p:txBody>
           <a:bodyPr rtlCol="0" anchor="ctr"/>
           <a:lstStyle/>
-          <a:p/>
+          <a:p>
+            <a:endParaRPr/>
+          </a:p>
         </p:txBody>
       </p:sp>
       <p:sp>
@@ -7385,7 +7572,9 @@
         <p:txBody>
           <a:bodyPr rtlCol="0" anchor="ctr"/>
           <a:lstStyle/>
-          <a:p/>
+          <a:p>
+            <a:endParaRPr/>
+          </a:p>
         </p:txBody>
       </p:sp>
       <p:sp>
@@ -7427,7 +7616,9 @@
         <p:txBody>
           <a:bodyPr rtlCol="0" anchor="ctr"/>
           <a:lstStyle/>
-          <a:p/>
+          <a:p>
+            <a:endParaRPr/>
+          </a:p>
         </p:txBody>
       </p:sp>
       <p:sp>
@@ -7469,7 +7660,9 @@
         <p:txBody>
           <a:bodyPr rtlCol="0" anchor="ctr"/>
           <a:lstStyle/>
-          <a:p/>
+          <a:p>
+            <a:endParaRPr/>
+          </a:p>
         </p:txBody>
       </p:sp>
       <p:sp>
@@ -7511,7 +7704,9 @@
         <p:txBody>
           <a:bodyPr rtlCol="0" anchor="ctr"/>
           <a:lstStyle/>
-          <a:p/>
+          <a:p>
+            <a:endParaRPr/>
+          </a:p>
         </p:txBody>
       </p:sp>
       <p:sp>
@@ -7553,7 +7748,9 @@
         <p:txBody>
           <a:bodyPr rtlCol="0" anchor="ctr"/>
           <a:lstStyle/>
-          <a:p/>
+          <a:p>
+            <a:endParaRPr/>
+          </a:p>
         </p:txBody>
       </p:sp>
       <p:sp>
@@ -7595,7 +7792,9 @@
         <p:txBody>
           <a:bodyPr rtlCol="0" anchor="ctr"/>
           <a:lstStyle/>
-          <a:p/>
+          <a:p>
+            <a:endParaRPr/>
+          </a:p>
         </p:txBody>
       </p:sp>
       <p:sp>
@@ -7637,7 +7836,9 @@
         <p:txBody>
           <a:bodyPr rtlCol="0" anchor="ctr"/>
           <a:lstStyle/>
-          <a:p/>
+          <a:p>
+            <a:endParaRPr/>
+          </a:p>
         </p:txBody>
       </p:sp>
       <p:sp>
@@ -7679,7 +7880,9 @@
         <p:txBody>
           <a:bodyPr rtlCol="0" anchor="ctr"/>
           <a:lstStyle/>
-          <a:p/>
+          <a:p>
+            <a:endParaRPr/>
+          </a:p>
         </p:txBody>
       </p:sp>
       <p:sp>
@@ -7721,7 +7924,9 @@
         <p:txBody>
           <a:bodyPr rtlCol="0" anchor="ctr"/>
           <a:lstStyle/>
-          <a:p/>
+          <a:p>
+            <a:endParaRPr/>
+          </a:p>
         </p:txBody>
       </p:sp>
       <p:sp>
@@ -7763,7 +7968,9 @@
         <p:txBody>
           <a:bodyPr rtlCol="0" anchor="ctr"/>
           <a:lstStyle/>
-          <a:p/>
+          <a:p>
+            <a:endParaRPr/>
+          </a:p>
         </p:txBody>
       </p:sp>
       <p:sp>
@@ -7805,7 +8012,9 @@
         <p:txBody>
           <a:bodyPr rtlCol="0" anchor="ctr"/>
           <a:lstStyle/>
-          <a:p/>
+          <a:p>
+            <a:endParaRPr/>
+          </a:p>
         </p:txBody>
       </p:sp>
       <p:sp>
@@ -7847,7 +8056,9 @@
         <p:txBody>
           <a:bodyPr rtlCol="0" anchor="ctr"/>
           <a:lstStyle/>
-          <a:p/>
+          <a:p>
+            <a:endParaRPr/>
+          </a:p>
         </p:txBody>
       </p:sp>
       <p:sp>
@@ -7889,7 +8100,9 @@
         <p:txBody>
           <a:bodyPr rtlCol="0" anchor="ctr"/>
           <a:lstStyle/>
-          <a:p/>
+          <a:p>
+            <a:endParaRPr/>
+          </a:p>
         </p:txBody>
       </p:sp>
       <p:sp>
@@ -7931,7 +8144,9 @@
         <p:txBody>
           <a:bodyPr rtlCol="0" anchor="ctr"/>
           <a:lstStyle/>
-          <a:p/>
+          <a:p>
+            <a:endParaRPr/>
+          </a:p>
         </p:txBody>
       </p:sp>
       <p:sp>
@@ -7973,7 +8188,9 @@
         <p:txBody>
           <a:bodyPr rtlCol="0" anchor="ctr"/>
           <a:lstStyle/>
-          <a:p/>
+          <a:p>
+            <a:endParaRPr/>
+          </a:p>
         </p:txBody>
       </p:sp>
       <p:sp>
@@ -7993,7 +8210,7 @@
           <a:noFill/>
         </p:spPr>
         <p:txBody>
-          <a:bodyPr wrap="square" lIns="0" rIns="0" tIns="0" bIns="0">
+          <a:bodyPr wrap="square" lIns="0" tIns="0" rIns="0" bIns="0">
             <a:spAutoFit/>
           </a:bodyPr>
           <a:lstStyle/>
@@ -8032,7 +8249,7 @@
           <a:noFill/>
         </p:spPr>
         <p:txBody>
-          <a:bodyPr wrap="square" lIns="0" rIns="0" tIns="0" bIns="0">
+          <a:bodyPr wrap="square" lIns="0" tIns="0" rIns="0" bIns="0">
             <a:spAutoFit/>
           </a:bodyPr>
           <a:lstStyle/>
@@ -8093,7 +8310,7 @@
           <a:noFill/>
         </p:spPr>
         <p:txBody>
-          <a:bodyPr wrap="square" lIns="0" rIns="0" tIns="0" bIns="0">
+          <a:bodyPr wrap="square" lIns="0" tIns="0" rIns="0" bIns="0">
             <a:spAutoFit/>
           </a:bodyPr>
           <a:lstStyle/>
@@ -8132,7 +8349,7 @@
           <a:noFill/>
         </p:spPr>
         <p:txBody>
-          <a:bodyPr wrap="square" lIns="0" rIns="0" tIns="0" bIns="0">
+          <a:bodyPr wrap="square" lIns="0" tIns="0" rIns="0" bIns="0">
             <a:spAutoFit/>
           </a:bodyPr>
           <a:lstStyle/>
@@ -8174,7 +8391,7 @@
           <a:noFill/>
         </p:spPr>
         <p:txBody>
-          <a:bodyPr wrap="square" lIns="0" rIns="0" tIns="0" bIns="0">
+          <a:bodyPr wrap="square" lIns="0" tIns="0" rIns="0" bIns="0">
             <a:spAutoFit/>
           </a:bodyPr>
           <a:lstStyle/>
@@ -8208,7 +8425,7 @@
 </file>
 
 <file path=ppt/slides/slide3.xml><?xml version="1.0" encoding="utf-8"?>
-<p:sld xmlns:a="http://schemas.openxmlformats.org/drawingml/2006/main" xmlns:p="http://schemas.openxmlformats.org/presentationml/2006/main" xmlns:r="http://schemas.openxmlformats.org/officeDocument/2006/relationships">
+<p:sld xmlns:a="http://schemas.openxmlformats.org/drawingml/2006/main" xmlns:r="http://schemas.openxmlformats.org/officeDocument/2006/relationships" xmlns:p="http://schemas.openxmlformats.org/presentationml/2006/main">
   <p:cSld>
     <p:spTree>
       <p:nvGrpSpPr>
@@ -8216,7 +8433,14 @@
         <p:cNvGrpSpPr/>
         <p:nvPr/>
       </p:nvGrpSpPr>
-      <p:grpSpPr/>
+      <p:grpSpPr>
+        <a:xfrm>
+          <a:off x="0" y="0"/>
+          <a:ext cx="0" cy="0"/>
+          <a:chOff x="0" y="0"/>
+          <a:chExt cx="0" cy="0"/>
+        </a:xfrm>
+      </p:grpSpPr>
       <p:sp>
         <p:nvSpPr>
           <p:cNvPr id="2" name="TextBox 1"/>
@@ -8234,7 +8458,7 @@
           <a:noFill/>
         </p:spPr>
         <p:txBody>
-          <a:bodyPr wrap="square" lIns="0" rIns="0" tIns="0" bIns="0">
+          <a:bodyPr wrap="square" lIns="0" tIns="0" rIns="0" bIns="0">
             <a:spAutoFit/>
           </a:bodyPr>
           <a:lstStyle/>
@@ -8273,7 +8497,7 @@
           <a:noFill/>
         </p:spPr>
         <p:txBody>
-          <a:bodyPr wrap="square" lIns="0" rIns="0" tIns="0" bIns="0">
+          <a:bodyPr wrap="square" lIns="0" tIns="0" rIns="0" bIns="0">
             <a:spAutoFit/>
           </a:bodyPr>
           <a:lstStyle/>
@@ -8410,7 +8634,7 @@
           <a:noFill/>
         </p:spPr>
         <p:txBody>
-          <a:bodyPr wrap="square" lIns="0" rIns="0" tIns="0" bIns="0">
+          <a:bodyPr wrap="square" lIns="0" tIns="0" rIns="0" bIns="0">
             <a:spAutoFit/>
           </a:bodyPr>
           <a:lstStyle/>
@@ -8449,7 +8673,7 @@
           <a:noFill/>
         </p:spPr>
         <p:txBody>
-          <a:bodyPr wrap="square" lIns="0" rIns="0" tIns="0" bIns="0">
+          <a:bodyPr wrap="square" lIns="0" tIns="0" rIns="0" bIns="0">
             <a:spAutoFit/>
           </a:bodyPr>
           <a:lstStyle/>
@@ -8491,7 +8715,7 @@
           <a:noFill/>
         </p:spPr>
         <p:txBody>
-          <a:bodyPr wrap="square" lIns="0" rIns="0" tIns="0" bIns="0">
+          <a:bodyPr wrap="square" lIns="0" tIns="0" rIns="0" bIns="0">
             <a:spAutoFit/>
           </a:bodyPr>
           <a:lstStyle/>
@@ -8530,7 +8754,7 @@
           <a:noFill/>
         </p:spPr>
         <p:txBody>
-          <a:bodyPr wrap="square" lIns="0" rIns="0" tIns="0" bIns="0">
+          <a:bodyPr wrap="square" lIns="0" tIns="0" rIns="0" bIns="0">
             <a:spAutoFit/>
           </a:bodyPr>
           <a:lstStyle/>
@@ -8572,7 +8796,7 @@
           <a:noFill/>
         </p:spPr>
         <p:txBody>
-          <a:bodyPr wrap="square" lIns="0" rIns="0" tIns="0" bIns="0">
+          <a:bodyPr wrap="square" lIns="0" tIns="0" rIns="0" bIns="0">
             <a:spAutoFit/>
           </a:bodyPr>
           <a:lstStyle/>
@@ -8611,7 +8835,7 @@
           <a:noFill/>
         </p:spPr>
         <p:txBody>
-          <a:bodyPr wrap="square" lIns="0" rIns="0" tIns="0" bIns="0">
+          <a:bodyPr wrap="square" lIns="0" tIns="0" rIns="0" bIns="0">
             <a:spAutoFit/>
           </a:bodyPr>
           <a:lstStyle/>
@@ -8653,7 +8877,7 @@
           <a:noFill/>
         </p:spPr>
         <p:txBody>
-          <a:bodyPr wrap="square" lIns="0" rIns="0" tIns="0" bIns="0">
+          <a:bodyPr wrap="square" lIns="0" tIns="0" rIns="0" bIns="0">
             <a:spAutoFit/>
           </a:bodyPr>
           <a:lstStyle/>
@@ -8687,7 +8911,7 @@
 </file>
 
 <file path=ppt/slides/slide4.xml><?xml version="1.0" encoding="utf-8"?>
-<p:sld xmlns:a="http://schemas.openxmlformats.org/drawingml/2006/main" xmlns:p="http://schemas.openxmlformats.org/presentationml/2006/main" xmlns:r="http://schemas.openxmlformats.org/officeDocument/2006/relationships">
+<p:sld xmlns:a="http://schemas.openxmlformats.org/drawingml/2006/main" xmlns:r="http://schemas.openxmlformats.org/officeDocument/2006/relationships" xmlns:p="http://schemas.openxmlformats.org/presentationml/2006/main">
   <p:cSld>
     <p:spTree>
       <p:nvGrpSpPr>
@@ -8695,7 +8919,14 @@
         <p:cNvGrpSpPr/>
         <p:nvPr/>
       </p:nvGrpSpPr>
-      <p:grpSpPr/>
+      <p:grpSpPr>
+        <a:xfrm>
+          <a:off x="0" y="0"/>
+          <a:ext cx="0" cy="0"/>
+          <a:chOff x="0" y="0"/>
+          <a:chExt cx="0" cy="0"/>
+        </a:xfrm>
+      </p:grpSpPr>
       <p:sp>
         <p:nvSpPr>
           <p:cNvPr id="2" name="TextBox 1"/>
@@ -8713,7 +8944,7 @@
           <a:noFill/>
         </p:spPr>
         <p:txBody>
-          <a:bodyPr wrap="square" lIns="0" rIns="0" tIns="0" bIns="0">
+          <a:bodyPr wrap="square" lIns="0" tIns="0" rIns="0" bIns="0">
             <a:spAutoFit/>
           </a:bodyPr>
           <a:lstStyle/>
@@ -8752,7 +8983,7 @@
           <a:noFill/>
         </p:spPr>
         <p:txBody>
-          <a:bodyPr wrap="square" lIns="0" rIns="0" tIns="0" bIns="0">
+          <a:bodyPr wrap="square" lIns="0" tIns="0" rIns="0" bIns="0">
             <a:spAutoFit/>
           </a:bodyPr>
           <a:lstStyle/>
@@ -8813,7 +9044,9 @@
         <p:txBody>
           <a:bodyPr rtlCol="0" anchor="ctr"/>
           <a:lstStyle/>
-          <a:p/>
+          <a:p>
+            <a:endParaRPr/>
+          </a:p>
         </p:txBody>
       </p:sp>
       <p:sp>
@@ -8890,7 +9123,9 @@
         <p:txBody>
           <a:bodyPr rtlCol="0" anchor="ctr"/>
           <a:lstStyle/>
-          <a:p/>
+          <a:p>
+            <a:endParaRPr/>
+          </a:p>
         </p:txBody>
       </p:sp>
       <p:sp>
@@ -8967,7 +9202,9 @@
         <p:txBody>
           <a:bodyPr rtlCol="0" anchor="ctr"/>
           <a:lstStyle/>
-          <a:p/>
+          <a:p>
+            <a:endParaRPr/>
+          </a:p>
         </p:txBody>
       </p:sp>
       <p:sp>
@@ -9044,7 +9281,9 @@
         <p:txBody>
           <a:bodyPr rtlCol="0" anchor="ctr"/>
           <a:lstStyle/>
-          <a:p/>
+          <a:p>
+            <a:endParaRPr/>
+          </a:p>
         </p:txBody>
       </p:sp>
       <p:sp>
@@ -9099,7 +9338,7 @@
           <a:noFill/>
         </p:spPr>
         <p:txBody>
-          <a:bodyPr wrap="square" lIns="0" rIns="0" tIns="0" bIns="0">
+          <a:bodyPr wrap="square" lIns="0" tIns="0" rIns="0" bIns="0">
             <a:spAutoFit/>
           </a:bodyPr>
           <a:lstStyle/>
@@ -9160,7 +9399,7 @@
           <a:noFill/>
         </p:spPr>
         <p:txBody>
-          <a:bodyPr wrap="square" lIns="0" rIns="0" tIns="0" bIns="0">
+          <a:bodyPr wrap="square" lIns="0" tIns="0" rIns="0" bIns="0">
             <a:spAutoFit/>
           </a:bodyPr>
           <a:lstStyle/>
@@ -9221,7 +9460,7 @@
           <a:noFill/>
         </p:spPr>
         <p:txBody>
-          <a:bodyPr wrap="square" lIns="0" rIns="0" tIns="0" bIns="0">
+          <a:bodyPr wrap="square" lIns="0" tIns="0" rIns="0" bIns="0">
             <a:spAutoFit/>
           </a:bodyPr>
           <a:lstStyle/>
@@ -9282,7 +9521,7 @@
           <a:noFill/>
         </p:spPr>
         <p:txBody>
-          <a:bodyPr wrap="square" lIns="0" rIns="0" tIns="0" bIns="0">
+          <a:bodyPr wrap="square" lIns="0" tIns="0" rIns="0" bIns="0">
             <a:spAutoFit/>
           </a:bodyPr>
           <a:lstStyle/>
@@ -9343,7 +9582,7 @@
           <a:noFill/>
         </p:spPr>
         <p:txBody>
-          <a:bodyPr wrap="square" lIns="0" rIns="0" tIns="0" bIns="0">
+          <a:bodyPr wrap="square" lIns="0" tIns="0" rIns="0" bIns="0">
             <a:spAutoFit/>
           </a:bodyPr>
           <a:lstStyle/>
@@ -9423,7 +9662,7 @@
           <a:noFill/>
         </p:spPr>
         <p:txBody>
-          <a:bodyPr wrap="square" lIns="0" rIns="0" tIns="0" bIns="0">
+          <a:bodyPr wrap="square" lIns="0" tIns="0" rIns="0" bIns="0">
             <a:spAutoFit/>
           </a:bodyPr>
           <a:lstStyle/>
@@ -9462,7 +9701,7 @@
           <a:noFill/>
         </p:spPr>
         <p:txBody>
-          <a:bodyPr wrap="square" lIns="0" rIns="0" tIns="0" bIns="0">
+          <a:bodyPr wrap="square" lIns="0" tIns="0" rIns="0" bIns="0">
             <a:spAutoFit/>
           </a:bodyPr>
           <a:lstStyle/>
@@ -9504,7 +9743,7 @@
           <a:noFill/>
         </p:spPr>
         <p:txBody>
-          <a:bodyPr wrap="square" lIns="0" rIns="0" tIns="0" bIns="0">
+          <a:bodyPr wrap="square" lIns="0" tIns="0" rIns="0" bIns="0">
             <a:spAutoFit/>
           </a:bodyPr>
           <a:lstStyle/>
@@ -9538,7 +9777,7 @@
 </file>
 
 <file path=ppt/slides/slide5.xml><?xml version="1.0" encoding="utf-8"?>
-<p:sld xmlns:a="http://schemas.openxmlformats.org/drawingml/2006/main" xmlns:p="http://schemas.openxmlformats.org/presentationml/2006/main" xmlns:r="http://schemas.openxmlformats.org/officeDocument/2006/relationships">
+<p:sld xmlns:a="http://schemas.openxmlformats.org/drawingml/2006/main" xmlns:r="http://schemas.openxmlformats.org/officeDocument/2006/relationships" xmlns:p="http://schemas.openxmlformats.org/presentationml/2006/main">
   <p:cSld>
     <p:spTree>
       <p:nvGrpSpPr>
@@ -9546,7 +9785,14 @@
         <p:cNvGrpSpPr/>
         <p:nvPr/>
       </p:nvGrpSpPr>
-      <p:grpSpPr/>
+      <p:grpSpPr>
+        <a:xfrm>
+          <a:off x="0" y="0"/>
+          <a:ext cx="0" cy="0"/>
+          <a:chOff x="0" y="0"/>
+          <a:chExt cx="0" cy="0"/>
+        </a:xfrm>
+      </p:grpSpPr>
       <p:sp>
         <p:nvSpPr>
           <p:cNvPr id="2" name="TextBox 1"/>
@@ -9564,7 +9810,7 @@
           <a:noFill/>
         </p:spPr>
         <p:txBody>
-          <a:bodyPr wrap="square" lIns="0" rIns="0" tIns="0" bIns="0">
+          <a:bodyPr wrap="square" lIns="0" tIns="0" rIns="0" bIns="0">
             <a:spAutoFit/>
           </a:bodyPr>
           <a:lstStyle/>
@@ -9603,7 +9849,7 @@
           <a:noFill/>
         </p:spPr>
         <p:txBody>
-          <a:bodyPr wrap="square" lIns="0" rIns="0" tIns="0" bIns="0">
+          <a:bodyPr wrap="square" lIns="0" tIns="0" rIns="0" bIns="0">
             <a:spAutoFit/>
           </a:bodyPr>
           <a:lstStyle/>
@@ -9666,7 +9912,7 @@
           <a:noFill/>
         </p:spPr>
         <p:txBody>
-          <a:bodyPr wrap="square" lIns="0" rIns="0" tIns="0" bIns="0">
+          <a:bodyPr wrap="square" lIns="0" tIns="0" rIns="0" bIns="0">
             <a:spAutoFit/>
           </a:bodyPr>
           <a:lstStyle/>
@@ -9805,14 +10051,32 @@
                 <a:tableStyleId>{5C22544A-7EE6-4342-B048-85BDC9FD1C3A}</a:tableStyleId>
               </a:tblPr>
               <a:tblGrid>
-                <a:gridCol w="1737360"/>
-                <a:gridCol w="1828800"/>
-                <a:gridCol w="1828800"/>
+                <a:gridCol w="1737360">
+                  <a:extLst>
+                    <a:ext uri="{9D8B030D-6E8A-4147-A177-3AD203B41FA5}">
+                      <a16:colId xmlns:a16="http://schemas.microsoft.com/office/drawing/2014/main" val="20000"/>
+                    </a:ext>
+                  </a:extLst>
+                </a:gridCol>
+                <a:gridCol w="1828800">
+                  <a:extLst>
+                    <a:ext uri="{9D8B030D-6E8A-4147-A177-3AD203B41FA5}">
+                      <a16:colId xmlns:a16="http://schemas.microsoft.com/office/drawing/2014/main" val="20001"/>
+                    </a:ext>
+                  </a:extLst>
+                </a:gridCol>
+                <a:gridCol w="1828800">
+                  <a:extLst>
+                    <a:ext uri="{9D8B030D-6E8A-4147-A177-3AD203B41FA5}">
+                      <a16:colId xmlns:a16="http://schemas.microsoft.com/office/drawing/2014/main" val="20002"/>
+                    </a:ext>
+                  </a:extLst>
+                </a:gridCol>
               </a:tblGrid>
               <a:tr h="365760">
                 <a:tc>
                   <a:txBody>
-                    <a:bodyPr wrap="square"/>
+                    <a:bodyPr/>
                     <a:lstStyle/>
                     <a:p>
                       <a:pPr algn="l"/>
@@ -9835,7 +10099,7 @@
                 </a:tc>
                 <a:tc>
                   <a:txBody>
-                    <a:bodyPr wrap="square"/>
+                    <a:bodyPr/>
                     <a:lstStyle/>
                     <a:p>
                       <a:pPr algn="r"/>
@@ -9858,7 +10122,7 @@
                 </a:tc>
                 <a:tc>
                   <a:txBody>
-                    <a:bodyPr wrap="square"/>
+                    <a:bodyPr/>
                     <a:lstStyle/>
                     <a:p>
                       <a:pPr algn="r"/>
@@ -9879,11 +10143,16 @@
                     </a:solidFill>
                   </a:tcPr>
                 </a:tc>
+                <a:extLst>
+                  <a:ext uri="{0D108BD9-81ED-4DB2-BD59-A6C34878D82A}">
+                    <a16:rowId xmlns:a16="http://schemas.microsoft.com/office/drawing/2014/main" val="10000"/>
+                  </a:ext>
+                </a:extLst>
               </a:tr>
               <a:tr h="365760">
                 <a:tc>
                   <a:txBody>
-                    <a:bodyPr wrap="square"/>
+                    <a:bodyPr/>
                     <a:lstStyle/>
                     <a:p>
                       <a:pPr algn="l"/>
@@ -9906,7 +10175,7 @@
                 </a:tc>
                 <a:tc>
                   <a:txBody>
-                    <a:bodyPr wrap="square"/>
+                    <a:bodyPr/>
                     <a:lstStyle/>
                     <a:p>
                       <a:pPr algn="r"/>
@@ -9929,7 +10198,7 @@
                 </a:tc>
                 <a:tc>
                   <a:txBody>
-                    <a:bodyPr wrap="square"/>
+                    <a:bodyPr/>
                     <a:lstStyle/>
                     <a:p>
                       <a:pPr algn="r"/>
@@ -9950,11 +10219,16 @@
                     </a:solidFill>
                   </a:tcPr>
                 </a:tc>
+                <a:extLst>
+                  <a:ext uri="{0D108BD9-81ED-4DB2-BD59-A6C34878D82A}">
+                    <a16:rowId xmlns:a16="http://schemas.microsoft.com/office/drawing/2014/main" val="10001"/>
+                  </a:ext>
+                </a:extLst>
               </a:tr>
               <a:tr h="365760">
                 <a:tc>
                   <a:txBody>
-                    <a:bodyPr wrap="square"/>
+                    <a:bodyPr/>
                     <a:lstStyle/>
                     <a:p>
                       <a:pPr algn="l"/>
@@ -9977,7 +10251,7 @@
                 </a:tc>
                 <a:tc>
                   <a:txBody>
-                    <a:bodyPr wrap="square"/>
+                    <a:bodyPr/>
                     <a:lstStyle/>
                     <a:p>
                       <a:pPr algn="r"/>
@@ -10000,7 +10274,7 @@
                 </a:tc>
                 <a:tc>
                   <a:txBody>
-                    <a:bodyPr wrap="square"/>
+                    <a:bodyPr/>
                     <a:lstStyle/>
                     <a:p>
                       <a:pPr algn="r"/>
@@ -10021,11 +10295,16 @@
                     </a:solidFill>
                   </a:tcPr>
                 </a:tc>
+                <a:extLst>
+                  <a:ext uri="{0D108BD9-81ED-4DB2-BD59-A6C34878D82A}">
+                    <a16:rowId xmlns:a16="http://schemas.microsoft.com/office/drawing/2014/main" val="10002"/>
+                  </a:ext>
+                </a:extLst>
               </a:tr>
               <a:tr h="365760">
                 <a:tc>
                   <a:txBody>
-                    <a:bodyPr wrap="square"/>
+                    <a:bodyPr/>
                     <a:lstStyle/>
                     <a:p>
                       <a:pPr algn="l"/>
@@ -10048,7 +10327,7 @@
                 </a:tc>
                 <a:tc>
                   <a:txBody>
-                    <a:bodyPr wrap="square"/>
+                    <a:bodyPr/>
                     <a:lstStyle/>
                     <a:p>
                       <a:pPr algn="r"/>
@@ -10071,7 +10350,7 @@
                 </a:tc>
                 <a:tc>
                   <a:txBody>
-                    <a:bodyPr wrap="square"/>
+                    <a:bodyPr/>
                     <a:lstStyle/>
                     <a:p>
                       <a:pPr algn="r"/>
@@ -10092,6 +10371,11 @@
                     </a:solidFill>
                   </a:tcPr>
                 </a:tc>
+                <a:extLst>
+                  <a:ext uri="{0D108BD9-81ED-4DB2-BD59-A6C34878D82A}">
+                    <a16:rowId xmlns:a16="http://schemas.microsoft.com/office/drawing/2014/main" val="10003"/>
+                  </a:ext>
+                </a:extLst>
               </a:tr>
             </a:tbl>
           </a:graphicData>
@@ -10114,7 +10398,7 @@
           <a:noFill/>
         </p:spPr>
         <p:txBody>
-          <a:bodyPr wrap="square" lIns="0" rIns="0" tIns="0" bIns="0">
+          <a:bodyPr wrap="square" lIns="0" tIns="0" rIns="0" bIns="0">
             <a:spAutoFit/>
           </a:bodyPr>
           <a:lstStyle/>
@@ -10156,7 +10440,7 @@
           <a:noFill/>
         </p:spPr>
         <p:txBody>
-          <a:bodyPr wrap="square" lIns="0" rIns="0" tIns="0" bIns="0">
+          <a:bodyPr wrap="square" lIns="0" tIns="0" rIns="0" bIns="0">
             <a:spAutoFit/>
           </a:bodyPr>
           <a:lstStyle/>
@@ -10190,7 +10474,7 @@
 </file>
 
 <file path=ppt/slides/slide6.xml><?xml version="1.0" encoding="utf-8"?>
-<p:sld xmlns:a="http://schemas.openxmlformats.org/drawingml/2006/main" xmlns:p="http://schemas.openxmlformats.org/presentationml/2006/main" xmlns:r="http://schemas.openxmlformats.org/officeDocument/2006/relationships">
+<p:sld xmlns:a="http://schemas.openxmlformats.org/drawingml/2006/main" xmlns:r="http://schemas.openxmlformats.org/officeDocument/2006/relationships" xmlns:p="http://schemas.openxmlformats.org/presentationml/2006/main">
   <p:cSld>
     <p:spTree>
       <p:nvGrpSpPr>
@@ -10198,7 +10482,14 @@
         <p:cNvGrpSpPr/>
         <p:nvPr/>
       </p:nvGrpSpPr>
-      <p:grpSpPr/>
+      <p:grpSpPr>
+        <a:xfrm>
+          <a:off x="0" y="0"/>
+          <a:ext cx="0" cy="0"/>
+          <a:chOff x="0" y="0"/>
+          <a:chExt cx="0" cy="0"/>
+        </a:xfrm>
+      </p:grpSpPr>
       <p:sp>
         <p:nvSpPr>
           <p:cNvPr id="2" name="TextBox 1"/>
@@ -10216,7 +10507,7 @@
           <a:noFill/>
         </p:spPr>
         <p:txBody>
-          <a:bodyPr wrap="square" lIns="0" rIns="0" tIns="0" bIns="0">
+          <a:bodyPr wrap="square" lIns="0" tIns="0" rIns="0" bIns="0">
             <a:spAutoFit/>
           </a:bodyPr>
           <a:lstStyle/>
@@ -10279,7 +10570,9 @@
         <p:txBody>
           <a:bodyPr rtlCol="0" anchor="ctr"/>
           <a:lstStyle/>
-          <a:p/>
+          <a:p>
+            <a:endParaRPr/>
+          </a:p>
         </p:txBody>
       </p:sp>
       <p:sp>
@@ -10299,7 +10592,7 @@
           <a:noFill/>
         </p:spPr>
         <p:txBody>
-          <a:bodyPr wrap="square" lIns="0" rIns="0" tIns="0" bIns="0">
+          <a:bodyPr wrap="square" lIns="0" tIns="0" rIns="0" bIns="0">
             <a:spAutoFit/>
           </a:bodyPr>
           <a:lstStyle/>
@@ -10338,7 +10631,7 @@
           <a:noFill/>
         </p:spPr>
         <p:txBody>
-          <a:bodyPr wrap="square" lIns="0" rIns="0" tIns="0" bIns="0">
+          <a:bodyPr wrap="square" lIns="0" tIns="0" rIns="0" bIns="0">
             <a:spAutoFit/>
           </a:bodyPr>
           <a:lstStyle/>
@@ -10401,7 +10694,9 @@
         <p:txBody>
           <a:bodyPr rtlCol="0" anchor="ctr"/>
           <a:lstStyle/>
-          <a:p/>
+          <a:p>
+            <a:endParaRPr/>
+          </a:p>
         </p:txBody>
       </p:sp>
       <p:sp>
@@ -10421,7 +10716,7 @@
           <a:noFill/>
         </p:spPr>
         <p:txBody>
-          <a:bodyPr wrap="square" lIns="0" rIns="0" tIns="0" bIns="0">
+          <a:bodyPr wrap="square" lIns="0" tIns="0" rIns="0" bIns="0">
             <a:spAutoFit/>
           </a:bodyPr>
           <a:lstStyle/>
@@ -10460,7 +10755,7 @@
           <a:noFill/>
         </p:spPr>
         <p:txBody>
-          <a:bodyPr wrap="square" lIns="0" rIns="0" tIns="0" bIns="0">
+          <a:bodyPr wrap="square" lIns="0" tIns="0" rIns="0" bIns="0">
             <a:spAutoFit/>
           </a:bodyPr>
           <a:lstStyle/>
@@ -10523,7 +10818,9 @@
         <p:txBody>
           <a:bodyPr rtlCol="0" anchor="ctr"/>
           <a:lstStyle/>
-          <a:p/>
+          <a:p>
+            <a:endParaRPr/>
+          </a:p>
         </p:txBody>
       </p:sp>
       <p:sp>
@@ -10543,7 +10840,7 @@
           <a:noFill/>
         </p:spPr>
         <p:txBody>
-          <a:bodyPr wrap="square" lIns="0" rIns="0" tIns="0" bIns="0">
+          <a:bodyPr wrap="square" lIns="0" tIns="0" rIns="0" bIns="0">
             <a:spAutoFit/>
           </a:bodyPr>
           <a:lstStyle/>
@@ -10582,7 +10879,7 @@
           <a:noFill/>
         </p:spPr>
         <p:txBody>
-          <a:bodyPr wrap="square" lIns="0" rIns="0" tIns="0" bIns="0">
+          <a:bodyPr wrap="square" lIns="0" tIns="0" rIns="0" bIns="0">
             <a:spAutoFit/>
           </a:bodyPr>
           <a:lstStyle/>
@@ -10645,7 +10942,9 @@
         <p:txBody>
           <a:bodyPr rtlCol="0" anchor="ctr"/>
           <a:lstStyle/>
-          <a:p/>
+          <a:p>
+            <a:endParaRPr/>
+          </a:p>
         </p:txBody>
       </p:sp>
       <p:sp>
@@ -10665,7 +10964,7 @@
           <a:noFill/>
         </p:spPr>
         <p:txBody>
-          <a:bodyPr wrap="square" lIns="0" rIns="0" tIns="0" bIns="0">
+          <a:bodyPr wrap="square" lIns="0" tIns="0" rIns="0" bIns="0">
             <a:spAutoFit/>
           </a:bodyPr>
           <a:lstStyle/>
@@ -10704,7 +11003,7 @@
           <a:noFill/>
         </p:spPr>
         <p:txBody>
-          <a:bodyPr wrap="square" lIns="0" rIns="0" tIns="0" bIns="0">
+          <a:bodyPr wrap="square" lIns="0" tIns="0" rIns="0" bIns="0">
             <a:spAutoFit/>
           </a:bodyPr>
           <a:lstStyle/>
@@ -10743,7 +11042,7 @@
           <a:noFill/>
         </p:spPr>
         <p:txBody>
-          <a:bodyPr wrap="square" lIns="0" rIns="0" tIns="0" bIns="0">
+          <a:bodyPr wrap="square" lIns="0" tIns="0" rIns="0" bIns="0">
             <a:spAutoFit/>
           </a:bodyPr>
           <a:lstStyle/>
@@ -10782,7 +11081,7 @@
           <a:noFill/>
         </p:spPr>
         <p:txBody>
-          <a:bodyPr wrap="square" lIns="0" rIns="0" tIns="0" bIns="0">
+          <a:bodyPr wrap="square" lIns="0" tIns="0" rIns="0" bIns="0">
             <a:spAutoFit/>
           </a:bodyPr>
           <a:lstStyle/>
@@ -10862,7 +11161,7 @@
           <a:noFill/>
         </p:spPr>
         <p:txBody>
-          <a:bodyPr wrap="square" lIns="0" rIns="0" tIns="0" bIns="0">
+          <a:bodyPr wrap="square" lIns="0" tIns="0" rIns="0" bIns="0">
             <a:spAutoFit/>
           </a:bodyPr>
           <a:lstStyle/>
@@ -10923,7 +11222,7 @@
           <a:noFill/>
         </p:spPr>
         <p:txBody>
-          <a:bodyPr wrap="square" lIns="0" rIns="0" tIns="0" bIns="0">
+          <a:bodyPr wrap="square" lIns="0" tIns="0" rIns="0" bIns="0">
             <a:spAutoFit/>
           </a:bodyPr>
           <a:lstStyle/>
@@ -10957,7 +11256,7 @@
 </file>
 
 <file path=ppt/slides/slide7.xml><?xml version="1.0" encoding="utf-8"?>
-<p:sld xmlns:a="http://schemas.openxmlformats.org/drawingml/2006/main" xmlns:p="http://schemas.openxmlformats.org/presentationml/2006/main" xmlns:r="http://schemas.openxmlformats.org/officeDocument/2006/relationships">
+<p:sld xmlns:a="http://schemas.openxmlformats.org/drawingml/2006/main" xmlns:r="http://schemas.openxmlformats.org/officeDocument/2006/relationships" xmlns:p="http://schemas.openxmlformats.org/presentationml/2006/main">
   <p:cSld>
     <p:spTree>
       <p:nvGrpSpPr>
@@ -10965,7 +11264,14 @@
         <p:cNvGrpSpPr/>
         <p:nvPr/>
       </p:nvGrpSpPr>
-      <p:grpSpPr/>
+      <p:grpSpPr>
+        <a:xfrm>
+          <a:off x="0" y="0"/>
+          <a:ext cx="0" cy="0"/>
+          <a:chOff x="0" y="0"/>
+          <a:chExt cx="0" cy="0"/>
+        </a:xfrm>
+      </p:grpSpPr>
       <p:sp>
         <p:nvSpPr>
           <p:cNvPr id="2" name="TextBox 1"/>
@@ -10983,7 +11289,7 @@
           <a:noFill/>
         </p:spPr>
         <p:txBody>
-          <a:bodyPr wrap="square" lIns="0" rIns="0" tIns="0" bIns="0">
+          <a:bodyPr wrap="square" lIns="0" tIns="0" rIns="0" bIns="0">
             <a:spAutoFit/>
           </a:bodyPr>
           <a:lstStyle/>
@@ -11022,7 +11328,7 @@
           <a:noFill/>
         </p:spPr>
         <p:txBody>
-          <a:bodyPr wrap="square" lIns="0" rIns="0" tIns="0" bIns="0">
+          <a:bodyPr wrap="square" lIns="0" tIns="0" rIns="0" bIns="0">
             <a:spAutoFit/>
           </a:bodyPr>
           <a:lstStyle/>
@@ -11064,7 +11370,7 @@
           <a:noFill/>
         </p:spPr>
         <p:txBody>
-          <a:bodyPr wrap="square" lIns="0" rIns="0" tIns="0" bIns="0">
+          <a:bodyPr wrap="square" lIns="0" tIns="0" rIns="0" bIns="0">
             <a:spAutoFit/>
           </a:bodyPr>
           <a:lstStyle/>
@@ -11125,7 +11431,9 @@
         <p:txBody>
           <a:bodyPr rtlCol="0" anchor="ctr"/>
           <a:lstStyle/>
-          <a:p/>
+          <a:p>
+            <a:endParaRPr/>
+          </a:p>
         </p:txBody>
       </p:sp>
       <p:sp>
@@ -11145,7 +11453,7 @@
           <a:noFill/>
         </p:spPr>
         <p:txBody>
-          <a:bodyPr wrap="square" lIns="0" rIns="0" tIns="0" bIns="0">
+          <a:bodyPr wrap="square" lIns="0" tIns="0" rIns="0" bIns="0">
             <a:spAutoFit/>
           </a:bodyPr>
           <a:lstStyle/>
@@ -11184,7 +11492,7 @@
           <a:noFill/>
         </p:spPr>
         <p:txBody>
-          <a:bodyPr wrap="square" lIns="0" rIns="0" tIns="0" bIns="0">
+          <a:bodyPr wrap="square" lIns="0" tIns="0" rIns="0" bIns="0">
             <a:spAutoFit/>
           </a:bodyPr>
           <a:lstStyle/>
@@ -11245,7 +11553,9 @@
         <p:txBody>
           <a:bodyPr rtlCol="0" anchor="ctr"/>
           <a:lstStyle/>
-          <a:p/>
+          <a:p>
+            <a:endParaRPr/>
+          </a:p>
         </p:txBody>
       </p:sp>
       <p:sp>
@@ -11265,7 +11575,7 @@
           <a:noFill/>
         </p:spPr>
         <p:txBody>
-          <a:bodyPr wrap="square" lIns="0" rIns="0" tIns="0" bIns="0">
+          <a:bodyPr wrap="square" lIns="0" tIns="0" rIns="0" bIns="0">
             <a:spAutoFit/>
           </a:bodyPr>
           <a:lstStyle/>
@@ -11304,7 +11614,7 @@
           <a:noFill/>
         </p:spPr>
         <p:txBody>
-          <a:bodyPr wrap="square" lIns="0" rIns="0" tIns="0" bIns="0">
+          <a:bodyPr wrap="square" lIns="0" tIns="0" rIns="0" bIns="0">
             <a:spAutoFit/>
           </a:bodyPr>
           <a:lstStyle/>
@@ -11343,7 +11653,7 @@
           <a:noFill/>
         </p:spPr>
         <p:txBody>
-          <a:bodyPr wrap="square" lIns="0" rIns="0" tIns="0" bIns="0">
+          <a:bodyPr wrap="square" lIns="0" tIns="0" rIns="0" bIns="0">
             <a:spAutoFit/>
           </a:bodyPr>
           <a:lstStyle/>
@@ -11382,7 +11692,7 @@
           <a:noFill/>
         </p:spPr>
         <p:txBody>
-          <a:bodyPr wrap="square" lIns="0" rIns="0" tIns="0" bIns="0">
+          <a:bodyPr wrap="square" lIns="0" tIns="0" rIns="0" bIns="0">
             <a:spAutoFit/>
           </a:bodyPr>
           <a:lstStyle/>
@@ -11481,7 +11791,7 @@
           <a:noFill/>
         </p:spPr>
         <p:txBody>
-          <a:bodyPr wrap="square" lIns="0" rIns="0" tIns="0" bIns="0">
+          <a:bodyPr wrap="square" lIns="0" tIns="0" rIns="0" bIns="0">
             <a:spAutoFit/>
           </a:bodyPr>
           <a:lstStyle/>
@@ -11515,7 +11825,7 @@
 </file>
 
 <file path=ppt/slides/slide8.xml><?xml version="1.0" encoding="utf-8"?>
-<p:sld xmlns:a="http://schemas.openxmlformats.org/drawingml/2006/main" xmlns:p="http://schemas.openxmlformats.org/presentationml/2006/main" xmlns:r="http://schemas.openxmlformats.org/officeDocument/2006/relationships">
+<p:sld xmlns:a="http://schemas.openxmlformats.org/drawingml/2006/main" xmlns:r="http://schemas.openxmlformats.org/officeDocument/2006/relationships" xmlns:p="http://schemas.openxmlformats.org/presentationml/2006/main">
   <p:cSld>
     <p:spTree>
       <p:nvGrpSpPr>
@@ -11523,7 +11833,14 @@
         <p:cNvGrpSpPr/>
         <p:nvPr/>
       </p:nvGrpSpPr>
-      <p:grpSpPr/>
+      <p:grpSpPr>
+        <a:xfrm>
+          <a:off x="0" y="0"/>
+          <a:ext cx="0" cy="0"/>
+          <a:chOff x="0" y="0"/>
+          <a:chExt cx="0" cy="0"/>
+        </a:xfrm>
+      </p:grpSpPr>
       <p:sp>
         <p:nvSpPr>
           <p:cNvPr id="2" name="TextBox 1"/>
@@ -11541,7 +11858,7 @@
           <a:noFill/>
         </p:spPr>
         <p:txBody>
-          <a:bodyPr wrap="square" lIns="0" rIns="0" tIns="0" bIns="0">
+          <a:bodyPr wrap="square" lIns="0" tIns="0" rIns="0" bIns="0">
             <a:spAutoFit/>
           </a:bodyPr>
           <a:lstStyle/>
@@ -11580,7 +11897,7 @@
           <a:noFill/>
         </p:spPr>
         <p:txBody>
-          <a:bodyPr wrap="square" lIns="0" rIns="0" tIns="0" bIns="0">
+          <a:bodyPr wrap="square" lIns="0" tIns="0" rIns="0" bIns="0">
             <a:spAutoFit/>
           </a:bodyPr>
           <a:lstStyle/>
@@ -11619,7 +11936,7 @@
           <a:noFill/>
         </p:spPr>
         <p:txBody>
-          <a:bodyPr wrap="square" lIns="0" rIns="0" tIns="0" bIns="0">
+          <a:bodyPr wrap="square" lIns="0" tIns="0" rIns="0" bIns="0">
             <a:spAutoFit/>
           </a:bodyPr>
           <a:lstStyle/>
@@ -11680,7 +11997,9 @@
         <p:txBody>
           <a:bodyPr rtlCol="0" anchor="ctr"/>
           <a:lstStyle/>
-          <a:p/>
+          <a:p>
+            <a:endParaRPr/>
+          </a:p>
         </p:txBody>
       </p:sp>
       <p:sp>
@@ -11700,7 +12019,7 @@
           <a:noFill/>
         </p:spPr>
         <p:txBody>
-          <a:bodyPr wrap="square" lIns="0" rIns="0" tIns="0" bIns="0">
+          <a:bodyPr wrap="square" lIns="0" tIns="0" rIns="0" bIns="0">
             <a:spAutoFit/>
           </a:bodyPr>
           <a:lstStyle/>
@@ -11739,7 +12058,7 @@
           <a:noFill/>
         </p:spPr>
         <p:txBody>
-          <a:bodyPr wrap="square" lIns="0" rIns="0" tIns="0" bIns="0">
+          <a:bodyPr wrap="square" lIns="0" tIns="0" rIns="0" bIns="0">
             <a:spAutoFit/>
           </a:bodyPr>
           <a:lstStyle/>
@@ -11800,7 +12119,9 @@
         <p:txBody>
           <a:bodyPr rtlCol="0" anchor="ctr"/>
           <a:lstStyle/>
-          <a:p/>
+          <a:p>
+            <a:endParaRPr/>
+          </a:p>
         </p:txBody>
       </p:sp>
       <p:sp>
@@ -11820,7 +12141,7 @@
           <a:noFill/>
         </p:spPr>
         <p:txBody>
-          <a:bodyPr wrap="square" lIns="0" rIns="0" tIns="0" bIns="0">
+          <a:bodyPr wrap="square" lIns="0" tIns="0" rIns="0" bIns="0">
             <a:spAutoFit/>
           </a:bodyPr>
           <a:lstStyle/>
@@ -11859,7 +12180,7 @@
           <a:noFill/>
         </p:spPr>
         <p:txBody>
-          <a:bodyPr wrap="square" lIns="0" rIns="0" tIns="0" bIns="0">
+          <a:bodyPr wrap="square" lIns="0" tIns="0" rIns="0" bIns="0">
             <a:spAutoFit/>
           </a:bodyPr>
           <a:lstStyle/>
@@ -11898,7 +12219,7 @@
           <a:noFill/>
         </p:spPr>
         <p:txBody>
-          <a:bodyPr wrap="square" lIns="0" rIns="0" tIns="0" bIns="0">
+          <a:bodyPr wrap="square" lIns="0" tIns="0" rIns="0" bIns="0">
             <a:spAutoFit/>
           </a:bodyPr>
           <a:lstStyle/>
@@ -11997,7 +12318,7 @@
           <a:noFill/>
         </p:spPr>
         <p:txBody>
-          <a:bodyPr wrap="square" lIns="0" rIns="0" tIns="0" bIns="0">
+          <a:bodyPr wrap="square" lIns="0" tIns="0" rIns="0" bIns="0">
             <a:spAutoFit/>
           </a:bodyPr>
           <a:lstStyle/>
@@ -12036,7 +12357,7 @@
           <a:noFill/>
         </p:spPr>
         <p:txBody>
-          <a:bodyPr wrap="square" lIns="0" rIns="0" tIns="0" bIns="0">
+          <a:bodyPr wrap="square" lIns="0" tIns="0" rIns="0" bIns="0">
             <a:spAutoFit/>
           </a:bodyPr>
           <a:lstStyle/>
@@ -12097,7 +12418,7 @@
           <a:noFill/>
         </p:spPr>
         <p:txBody>
-          <a:bodyPr wrap="square" lIns="0" rIns="0" tIns="0" bIns="0">
+          <a:bodyPr wrap="square" lIns="0" tIns="0" rIns="0" bIns="0">
             <a:spAutoFit/>
           </a:bodyPr>
           <a:lstStyle/>
@@ -12158,7 +12479,7 @@
           <a:noFill/>
         </p:spPr>
         <p:txBody>
-          <a:bodyPr wrap="square" lIns="0" rIns="0" tIns="0" bIns="0">
+          <a:bodyPr wrap="square" lIns="0" tIns="0" rIns="0" bIns="0">
             <a:spAutoFit/>
           </a:bodyPr>
           <a:lstStyle/>
@@ -12192,7 +12513,7 @@
 </file>
 
 <file path=ppt/slides/slide9.xml><?xml version="1.0" encoding="utf-8"?>
-<p:sld xmlns:a="http://schemas.openxmlformats.org/drawingml/2006/main" xmlns:p="http://schemas.openxmlformats.org/presentationml/2006/main" xmlns:r="http://schemas.openxmlformats.org/officeDocument/2006/relationships">
+<p:sld xmlns:a="http://schemas.openxmlformats.org/drawingml/2006/main" xmlns:r="http://schemas.openxmlformats.org/officeDocument/2006/relationships" xmlns:p="http://schemas.openxmlformats.org/presentationml/2006/main">
   <p:cSld>
     <p:spTree>
       <p:nvGrpSpPr>
@@ -12200,7 +12521,14 @@
         <p:cNvGrpSpPr/>
         <p:nvPr/>
       </p:nvGrpSpPr>
-      <p:grpSpPr/>
+      <p:grpSpPr>
+        <a:xfrm>
+          <a:off x="0" y="0"/>
+          <a:ext cx="0" cy="0"/>
+          <a:chOff x="0" y="0"/>
+          <a:chExt cx="0" cy="0"/>
+        </a:xfrm>
+      </p:grpSpPr>
       <p:sp>
         <p:nvSpPr>
           <p:cNvPr id="2" name="TextBox 1"/>
@@ -12218,7 +12546,7 @@
           <a:noFill/>
         </p:spPr>
         <p:txBody>
-          <a:bodyPr wrap="square" lIns="0" rIns="0" tIns="0" bIns="0">
+          <a:bodyPr wrap="square" lIns="0" tIns="0" rIns="0" bIns="0">
             <a:spAutoFit/>
           </a:bodyPr>
           <a:lstStyle/>
@@ -12257,7 +12585,7 @@
           <a:noFill/>
         </p:spPr>
         <p:txBody>
-          <a:bodyPr wrap="square" lIns="0" rIns="0" tIns="0" bIns="0">
+          <a:bodyPr wrap="square" lIns="0" tIns="0" rIns="0" bIns="0">
             <a:spAutoFit/>
           </a:bodyPr>
           <a:lstStyle/>
@@ -12318,7 +12646,9 @@
         <p:txBody>
           <a:bodyPr rtlCol="0" anchor="ctr"/>
           <a:lstStyle/>
-          <a:p/>
+          <a:p>
+            <a:endParaRPr/>
+          </a:p>
         </p:txBody>
       </p:sp>
       <p:sp>
@@ -12338,7 +12668,7 @@
           <a:noFill/>
         </p:spPr>
         <p:txBody>
-          <a:bodyPr wrap="square" lIns="0" rIns="0" tIns="0" bIns="0">
+          <a:bodyPr wrap="square" lIns="0" tIns="0" rIns="0" bIns="0">
             <a:spAutoFit/>
           </a:bodyPr>
           <a:lstStyle/>
@@ -12377,7 +12707,7 @@
           <a:noFill/>
         </p:spPr>
         <p:txBody>
-          <a:bodyPr wrap="square" lIns="0" rIns="0" tIns="0" bIns="0">
+          <a:bodyPr wrap="square" lIns="0" tIns="0" rIns="0" bIns="0">
             <a:spAutoFit/>
           </a:bodyPr>
           <a:lstStyle/>
@@ -12419,7 +12749,7 @@
           <a:noFill/>
         </p:spPr>
         <p:txBody>
-          <a:bodyPr wrap="square" lIns="0" rIns="0" tIns="0" bIns="0">
+          <a:bodyPr wrap="square" lIns="0" tIns="0" rIns="0" bIns="0">
             <a:spAutoFit/>
           </a:bodyPr>
           <a:lstStyle/>
@@ -12484,7 +12814,9 @@
         <p:txBody>
           <a:bodyPr rtlCol="0" anchor="ctr"/>
           <a:lstStyle/>
-          <a:p/>
+          <a:p>
+            <a:endParaRPr/>
+          </a:p>
         </p:txBody>
       </p:sp>
       <p:sp>
@@ -12504,7 +12836,7 @@
           <a:noFill/>
         </p:spPr>
         <p:txBody>
-          <a:bodyPr wrap="square" lIns="0" rIns="0" tIns="0" bIns="0">
+          <a:bodyPr wrap="square" lIns="0" tIns="0" rIns="0" bIns="0">
             <a:spAutoFit/>
           </a:bodyPr>
           <a:lstStyle/>
@@ -12543,7 +12875,7 @@
           <a:noFill/>
         </p:spPr>
         <p:txBody>
-          <a:bodyPr wrap="square" lIns="0" rIns="0" tIns="0" bIns="0">
+          <a:bodyPr wrap="square" lIns="0" tIns="0" rIns="0" bIns="0">
             <a:spAutoFit/>
           </a:bodyPr>
           <a:lstStyle/>
@@ -12585,7 +12917,7 @@
           <a:noFill/>
         </p:spPr>
         <p:txBody>
-          <a:bodyPr wrap="square" lIns="0" rIns="0" tIns="0" bIns="0">
+          <a:bodyPr wrap="square" lIns="0" tIns="0" rIns="0" bIns="0">
             <a:spAutoFit/>
           </a:bodyPr>
           <a:lstStyle/>
@@ -12650,7 +12982,9 @@
         <p:txBody>
           <a:bodyPr rtlCol="0" anchor="ctr"/>
           <a:lstStyle/>
-          <a:p/>
+          <a:p>
+            <a:endParaRPr/>
+          </a:p>
         </p:txBody>
       </p:sp>
       <p:sp>
@@ -12670,7 +13004,7 @@
           <a:noFill/>
         </p:spPr>
         <p:txBody>
-          <a:bodyPr wrap="square" lIns="0" rIns="0" tIns="0" bIns="0">
+          <a:bodyPr wrap="square" lIns="0" tIns="0" rIns="0" bIns="0">
             <a:spAutoFit/>
           </a:bodyPr>
           <a:lstStyle/>
@@ -12709,7 +13043,7 @@
           <a:noFill/>
         </p:spPr>
         <p:txBody>
-          <a:bodyPr wrap="square" lIns="0" rIns="0" tIns="0" bIns="0">
+          <a:bodyPr wrap="square" lIns="0" tIns="0" rIns="0" bIns="0">
             <a:spAutoFit/>
           </a:bodyPr>
           <a:lstStyle/>
@@ -12751,7 +13085,7 @@
           <a:noFill/>
         </p:spPr>
         <p:txBody>
-          <a:bodyPr wrap="square" lIns="0" rIns="0" tIns="0" bIns="0">
+          <a:bodyPr wrap="square" lIns="0" tIns="0" rIns="0" bIns="0">
             <a:spAutoFit/>
           </a:bodyPr>
           <a:lstStyle/>
@@ -12794,7 +13128,7 @@
           <a:noFill/>
         </p:spPr>
         <p:txBody>
-          <a:bodyPr wrap="square" lIns="0" rIns="0" tIns="0" bIns="0">
+          <a:bodyPr wrap="square" lIns="0" tIns="0" rIns="0" bIns="0">
             <a:spAutoFit/>
           </a:bodyPr>
           <a:lstStyle/>

</xml_diff>